<commit_message>
feat: improve gap tolerance selection by introducing preference margin
</commit_message>
<xml_diff>
--- a/demo/office_docs/pptx_01.pptx
+++ b/demo/office_docs/pptx_01.pptx
@@ -5,13 +5,14 @@
     <p:sldMasterId id="2147483648" r:id="rId1"/>
   </p:sldMasterIdLst>
   <p:notesMasterIdLst>
-    <p:notesMasterId r:id="rId5"/>
+    <p:notesMasterId r:id="rId7"/>
   </p:notesMasterIdLst>
   <p:sldIdLst>
-    <p:sldId id="256" r:id="rId3"/>
-    <p:sldId id="257" r:id="rId4"/>
-    <p:sldId id="258" r:id="rId6"/>
-    <p:sldId id="259" r:id="rId7"/>
+    <p:sldId id="256" r:id="rId2"/>
+    <p:sldId id="257" r:id="rId3"/>
+    <p:sldId id="258" r:id="rId4"/>
+    <p:sldId id="259" r:id="rId5"/>
+    <p:sldId id="260" r:id="rId6"/>
   </p:sldIdLst>
   <p:sldSz cx="12192000" cy="6858000"/>
   <p:notesSz cx="6858000" cy="9144000"/>
@@ -110,7 +111,1012 @@
       </a:defRPr>
     </a:lvl9pPr>
   </p:defaultTextStyle>
+  <p:extLst>
+    <p:ext uri="{EFAFB233-063F-42B5-8137-9DF3F51BA10A}">
+      <p15:sldGuideLst xmlns:p15="http://schemas.microsoft.com/office/powerpoint/2012/main"/>
+    </p:ext>
+  </p:extLst>
 </p:presentation>
+</file>
+
+<file path=ppt/charts/chart1.xml><?xml version="1.0" encoding="utf-8"?>
+<c:chartSpace xmlns:c="http://schemas.openxmlformats.org/drawingml/2006/chart" xmlns:a="http://schemas.openxmlformats.org/drawingml/2006/main" xmlns:r="http://schemas.openxmlformats.org/officeDocument/2006/relationships" xmlns:c16r2="http://schemas.microsoft.com/office/drawing/2015/06/chart">
+  <c:date1904 val="0"/>
+  <c:lang val="zh-CN"/>
+  <c:roundedCorners val="0"/>
+  <mc:AlternateContent xmlns:mc="http://schemas.openxmlformats.org/markup-compatibility/2006">
+    <mc:Choice xmlns:c14="http://schemas.microsoft.com/office/drawing/2007/8/2/chart" Requires="c14">
+      <c14:style val="102"/>
+    </mc:Choice>
+    <mc:Fallback>
+      <c:style val="2"/>
+    </mc:Fallback>
+  </mc:AlternateContent>
+  <c:chart>
+    <c:title>
+      <c:overlay val="0"/>
+      <c:spPr>
+        <a:noFill/>
+        <a:ln>
+          <a:noFill/>
+        </a:ln>
+        <a:effectLst/>
+      </c:spPr>
+      <c:txPr>
+        <a:bodyPr rot="0" spcFirstLastPara="1" vertOverflow="ellipsis" vert="horz" wrap="square" anchor="ctr" anchorCtr="1"/>
+        <a:lstStyle/>
+        <a:p>
+          <a:pPr>
+            <a:defRPr sz="1862" b="0" i="0" u="none" strike="noStrike" kern="1200" spc="0" baseline="0">
+              <a:solidFill>
+                <a:schemeClr val="tx1">
+                  <a:lumMod val="65000"/>
+                  <a:lumOff val="35000"/>
+                </a:schemeClr>
+              </a:solidFill>
+              <a:latin typeface="+mn-lt"/>
+              <a:ea typeface="+mn-ea"/>
+              <a:cs typeface="+mn-cs"/>
+            </a:defRPr>
+          </a:pPr>
+          <a:endParaRPr lang="zh-CN"/>
+        </a:p>
+      </c:txPr>
+    </c:title>
+    <c:autoTitleDeleted val="0"/>
+    <c:plotArea>
+      <c:layout/>
+      <c:barChart>
+        <c:barDir val="col"/>
+        <c:grouping val="clustered"/>
+        <c:varyColors val="0"/>
+        <c:ser>
+          <c:idx val="0"/>
+          <c:order val="0"/>
+          <c:tx>
+            <c:strRef>
+              <c:f>Sheet1!$B$1</c:f>
+              <c:strCache>
+                <c:ptCount val="1"/>
+                <c:pt idx="0">
+                  <c:v>系列 1</c:v>
+                </c:pt>
+              </c:strCache>
+            </c:strRef>
+          </c:tx>
+          <c:spPr>
+            <a:solidFill>
+              <a:schemeClr val="accent1"/>
+            </a:solidFill>
+            <a:ln>
+              <a:noFill/>
+            </a:ln>
+            <a:effectLst/>
+          </c:spPr>
+          <c:invertIfNegative val="0"/>
+          <c:cat>
+            <c:strRef>
+              <c:f>Sheet1!$A$2:$A$5</c:f>
+              <c:strCache>
+                <c:ptCount val="4"/>
+                <c:pt idx="0">
+                  <c:v>类别 1</c:v>
+                </c:pt>
+                <c:pt idx="1">
+                  <c:v>类别 2</c:v>
+                </c:pt>
+                <c:pt idx="2">
+                  <c:v>类别 3</c:v>
+                </c:pt>
+                <c:pt idx="3">
+                  <c:v>类别 4</c:v>
+                </c:pt>
+              </c:strCache>
+            </c:strRef>
+          </c:cat>
+          <c:val>
+            <c:numRef>
+              <c:f>Sheet1!$B$2:$B$5</c:f>
+              <c:numCache>
+                <c:formatCode>General</c:formatCode>
+                <c:ptCount val="4"/>
+                <c:pt idx="0">
+                  <c:v>4.3</c:v>
+                </c:pt>
+                <c:pt idx="1">
+                  <c:v>2.5</c:v>
+                </c:pt>
+                <c:pt idx="2">
+                  <c:v>3.5</c:v>
+                </c:pt>
+                <c:pt idx="3">
+                  <c:v>4.5</c:v>
+                </c:pt>
+              </c:numCache>
+            </c:numRef>
+          </c:val>
+          <c:extLst>
+            <c:ext xmlns:c16="http://schemas.microsoft.com/office/drawing/2014/chart" uri="{C3380CC4-5D6E-409C-BE32-E72D297353CC}">
+              <c16:uniqueId val="{00000000-464A-024E-BE34-3EE93E0A6159}"/>
+            </c:ext>
+          </c:extLst>
+        </c:ser>
+        <c:ser>
+          <c:idx val="1"/>
+          <c:order val="1"/>
+          <c:tx>
+            <c:strRef>
+              <c:f>Sheet1!$C$1</c:f>
+              <c:strCache>
+                <c:ptCount val="1"/>
+                <c:pt idx="0">
+                  <c:v>系列 2</c:v>
+                </c:pt>
+              </c:strCache>
+            </c:strRef>
+          </c:tx>
+          <c:spPr>
+            <a:solidFill>
+              <a:schemeClr val="accent2"/>
+            </a:solidFill>
+            <a:ln>
+              <a:noFill/>
+            </a:ln>
+            <a:effectLst/>
+          </c:spPr>
+          <c:invertIfNegative val="0"/>
+          <c:cat>
+            <c:strRef>
+              <c:f>Sheet1!$A$2:$A$5</c:f>
+              <c:strCache>
+                <c:ptCount val="4"/>
+                <c:pt idx="0">
+                  <c:v>类别 1</c:v>
+                </c:pt>
+                <c:pt idx="1">
+                  <c:v>类别 2</c:v>
+                </c:pt>
+                <c:pt idx="2">
+                  <c:v>类别 3</c:v>
+                </c:pt>
+                <c:pt idx="3">
+                  <c:v>类别 4</c:v>
+                </c:pt>
+              </c:strCache>
+            </c:strRef>
+          </c:cat>
+          <c:val>
+            <c:numRef>
+              <c:f>Sheet1!$C$2:$C$5</c:f>
+              <c:numCache>
+                <c:formatCode>General</c:formatCode>
+                <c:ptCount val="4"/>
+                <c:pt idx="0">
+                  <c:v>2.4</c:v>
+                </c:pt>
+                <c:pt idx="1">
+                  <c:v>4.4000000000000004</c:v>
+                </c:pt>
+                <c:pt idx="2">
+                  <c:v>1.8</c:v>
+                </c:pt>
+                <c:pt idx="3">
+                  <c:v>2.8</c:v>
+                </c:pt>
+              </c:numCache>
+            </c:numRef>
+          </c:val>
+          <c:extLst>
+            <c:ext xmlns:c16="http://schemas.microsoft.com/office/drawing/2014/chart" uri="{C3380CC4-5D6E-409C-BE32-E72D297353CC}">
+              <c16:uniqueId val="{00000001-464A-024E-BE34-3EE93E0A6159}"/>
+            </c:ext>
+          </c:extLst>
+        </c:ser>
+        <c:ser>
+          <c:idx val="2"/>
+          <c:order val="2"/>
+          <c:tx>
+            <c:strRef>
+              <c:f>Sheet1!$D$1</c:f>
+              <c:strCache>
+                <c:ptCount val="1"/>
+                <c:pt idx="0">
+                  <c:v>系列 3</c:v>
+                </c:pt>
+              </c:strCache>
+            </c:strRef>
+          </c:tx>
+          <c:spPr>
+            <a:solidFill>
+              <a:schemeClr val="accent3"/>
+            </a:solidFill>
+            <a:ln>
+              <a:noFill/>
+            </a:ln>
+            <a:effectLst/>
+          </c:spPr>
+          <c:invertIfNegative val="0"/>
+          <c:cat>
+            <c:strRef>
+              <c:f>Sheet1!$A$2:$A$5</c:f>
+              <c:strCache>
+                <c:ptCount val="4"/>
+                <c:pt idx="0">
+                  <c:v>类别 1</c:v>
+                </c:pt>
+                <c:pt idx="1">
+                  <c:v>类别 2</c:v>
+                </c:pt>
+                <c:pt idx="2">
+                  <c:v>类别 3</c:v>
+                </c:pt>
+                <c:pt idx="3">
+                  <c:v>类别 4</c:v>
+                </c:pt>
+              </c:strCache>
+            </c:strRef>
+          </c:cat>
+          <c:val>
+            <c:numRef>
+              <c:f>Sheet1!$D$2:$D$5</c:f>
+              <c:numCache>
+                <c:formatCode>General</c:formatCode>
+                <c:ptCount val="4"/>
+                <c:pt idx="0">
+                  <c:v>2</c:v>
+                </c:pt>
+                <c:pt idx="1">
+                  <c:v>2</c:v>
+                </c:pt>
+                <c:pt idx="2">
+                  <c:v>3</c:v>
+                </c:pt>
+                <c:pt idx="3">
+                  <c:v>5</c:v>
+                </c:pt>
+              </c:numCache>
+            </c:numRef>
+          </c:val>
+          <c:extLst>
+            <c:ext xmlns:c16="http://schemas.microsoft.com/office/drawing/2014/chart" uri="{C3380CC4-5D6E-409C-BE32-E72D297353CC}">
+              <c16:uniqueId val="{00000002-464A-024E-BE34-3EE93E0A6159}"/>
+            </c:ext>
+          </c:extLst>
+        </c:ser>
+        <c:dLbls>
+          <c:showLegendKey val="0"/>
+          <c:showVal val="0"/>
+          <c:showCatName val="0"/>
+          <c:showSerName val="0"/>
+          <c:showPercent val="0"/>
+          <c:showBubbleSize val="0"/>
+        </c:dLbls>
+        <c:gapWidth val="219"/>
+        <c:overlap val="-27"/>
+        <c:axId val="354153599"/>
+        <c:axId val="354146879"/>
+      </c:barChart>
+      <c:catAx>
+        <c:axId val="354153599"/>
+        <c:scaling>
+          <c:orientation val="minMax"/>
+        </c:scaling>
+        <c:delete val="0"/>
+        <c:axPos val="b"/>
+        <c:numFmt formatCode="General" sourceLinked="1"/>
+        <c:majorTickMark val="none"/>
+        <c:minorTickMark val="none"/>
+        <c:tickLblPos val="nextTo"/>
+        <c:spPr>
+          <a:noFill/>
+          <a:ln w="9525" cap="flat" cmpd="sng" algn="ctr">
+            <a:solidFill>
+              <a:schemeClr val="tx1">
+                <a:lumMod val="15000"/>
+                <a:lumOff val="85000"/>
+              </a:schemeClr>
+            </a:solidFill>
+            <a:round/>
+          </a:ln>
+          <a:effectLst/>
+        </c:spPr>
+        <c:txPr>
+          <a:bodyPr rot="-60000000" spcFirstLastPara="1" vertOverflow="ellipsis" vert="horz" wrap="square" anchor="ctr" anchorCtr="1"/>
+          <a:lstStyle/>
+          <a:p>
+            <a:pPr>
+              <a:defRPr sz="1197" b="0" i="0" u="none" strike="noStrike" kern="1200" baseline="0">
+                <a:solidFill>
+                  <a:schemeClr val="tx1">
+                    <a:lumMod val="65000"/>
+                    <a:lumOff val="35000"/>
+                  </a:schemeClr>
+                </a:solidFill>
+                <a:latin typeface="+mn-lt"/>
+                <a:ea typeface="+mn-ea"/>
+                <a:cs typeface="+mn-cs"/>
+              </a:defRPr>
+            </a:pPr>
+            <a:endParaRPr lang="zh-CN"/>
+          </a:p>
+        </c:txPr>
+        <c:crossAx val="354146879"/>
+        <c:crosses val="autoZero"/>
+        <c:auto val="1"/>
+        <c:lblAlgn val="ctr"/>
+        <c:lblOffset val="100"/>
+        <c:noMultiLvlLbl val="0"/>
+      </c:catAx>
+      <c:valAx>
+        <c:axId val="354146879"/>
+        <c:scaling>
+          <c:orientation val="minMax"/>
+        </c:scaling>
+        <c:delete val="0"/>
+        <c:axPos val="l"/>
+        <c:majorGridlines>
+          <c:spPr>
+            <a:ln w="9525" cap="flat" cmpd="sng" algn="ctr">
+              <a:solidFill>
+                <a:schemeClr val="tx1">
+                  <a:lumMod val="15000"/>
+                  <a:lumOff val="85000"/>
+                </a:schemeClr>
+              </a:solidFill>
+              <a:round/>
+            </a:ln>
+            <a:effectLst/>
+          </c:spPr>
+        </c:majorGridlines>
+        <c:numFmt formatCode="General" sourceLinked="1"/>
+        <c:majorTickMark val="none"/>
+        <c:minorTickMark val="none"/>
+        <c:tickLblPos val="nextTo"/>
+        <c:spPr>
+          <a:noFill/>
+          <a:ln>
+            <a:noFill/>
+          </a:ln>
+          <a:effectLst/>
+        </c:spPr>
+        <c:txPr>
+          <a:bodyPr rot="-60000000" spcFirstLastPara="1" vertOverflow="ellipsis" vert="horz" wrap="square" anchor="ctr" anchorCtr="1"/>
+          <a:lstStyle/>
+          <a:p>
+            <a:pPr>
+              <a:defRPr sz="1197" b="0" i="0" u="none" strike="noStrike" kern="1200" baseline="0">
+                <a:solidFill>
+                  <a:schemeClr val="tx1">
+                    <a:lumMod val="65000"/>
+                    <a:lumOff val="35000"/>
+                  </a:schemeClr>
+                </a:solidFill>
+                <a:latin typeface="+mn-lt"/>
+                <a:ea typeface="+mn-ea"/>
+                <a:cs typeface="+mn-cs"/>
+              </a:defRPr>
+            </a:pPr>
+            <a:endParaRPr lang="zh-CN"/>
+          </a:p>
+        </c:txPr>
+        <c:crossAx val="354153599"/>
+        <c:crosses val="autoZero"/>
+        <c:crossBetween val="between"/>
+      </c:valAx>
+      <c:spPr>
+        <a:noFill/>
+        <a:ln>
+          <a:noFill/>
+        </a:ln>
+        <a:effectLst/>
+      </c:spPr>
+    </c:plotArea>
+    <c:legend>
+      <c:legendPos val="b"/>
+      <c:overlay val="0"/>
+      <c:spPr>
+        <a:noFill/>
+        <a:ln>
+          <a:noFill/>
+        </a:ln>
+        <a:effectLst/>
+      </c:spPr>
+      <c:txPr>
+        <a:bodyPr rot="0" spcFirstLastPara="1" vertOverflow="ellipsis" vert="horz" wrap="square" anchor="ctr" anchorCtr="1"/>
+        <a:lstStyle/>
+        <a:p>
+          <a:pPr>
+            <a:defRPr sz="1197" b="0" i="0" u="none" strike="noStrike" kern="1200" baseline="0">
+              <a:solidFill>
+                <a:schemeClr val="tx1">
+                  <a:lumMod val="65000"/>
+                  <a:lumOff val="35000"/>
+                </a:schemeClr>
+              </a:solidFill>
+              <a:latin typeface="+mn-lt"/>
+              <a:ea typeface="+mn-ea"/>
+              <a:cs typeface="+mn-cs"/>
+            </a:defRPr>
+          </a:pPr>
+          <a:endParaRPr lang="zh-CN"/>
+        </a:p>
+      </c:txPr>
+    </c:legend>
+    <c:plotVisOnly val="1"/>
+    <c:dispBlanksAs val="gap"/>
+    <c:showDLblsOverMax val="0"/>
+    <c:extLst>
+      <c:ext xmlns:c16r3="http://schemas.microsoft.com/office/drawing/2017/03/chart" uri="{56B9EC1D-385E-4148-901F-78D8002777C0}">
+        <c16r3:dataDisplayOptions16>
+          <c16r3:dispNaAsBlank val="1"/>
+        </c16r3:dataDisplayOptions16>
+      </c:ext>
+    </c:extLst>
+  </c:chart>
+  <c:spPr>
+    <a:noFill/>
+    <a:ln>
+      <a:noFill/>
+    </a:ln>
+    <a:effectLst/>
+  </c:spPr>
+  <c:txPr>
+    <a:bodyPr/>
+    <a:lstStyle/>
+    <a:p>
+      <a:pPr>
+        <a:defRPr/>
+      </a:pPr>
+      <a:endParaRPr lang="zh-CN"/>
+    </a:p>
+  </c:txPr>
+  <c:externalData r:id="rId3">
+    <c:autoUpdate val="0"/>
+  </c:externalData>
+</c:chartSpace>
+</file>
+
+<file path=ppt/charts/colors1.xml><?xml version="1.0" encoding="utf-8"?>
+<cs:colorStyle xmlns:cs="http://schemas.microsoft.com/office/drawing/2012/chartStyle" xmlns:a="http://schemas.openxmlformats.org/drawingml/2006/main" meth="cycle" id="10">
+  <a:schemeClr val="accent1"/>
+  <a:schemeClr val="accent2"/>
+  <a:schemeClr val="accent3"/>
+  <a:schemeClr val="accent4"/>
+  <a:schemeClr val="accent5"/>
+  <a:schemeClr val="accent6"/>
+  <cs:variation/>
+  <cs:variation>
+    <a:lumMod val="60000"/>
+  </cs:variation>
+  <cs:variation>
+    <a:lumMod val="80000"/>
+    <a:lumOff val="20000"/>
+  </cs:variation>
+  <cs:variation>
+    <a:lumMod val="80000"/>
+  </cs:variation>
+  <cs:variation>
+    <a:lumMod val="60000"/>
+    <a:lumOff val="40000"/>
+  </cs:variation>
+  <cs:variation>
+    <a:lumMod val="50000"/>
+  </cs:variation>
+  <cs:variation>
+    <a:lumMod val="70000"/>
+    <a:lumOff val="30000"/>
+  </cs:variation>
+  <cs:variation>
+    <a:lumMod val="70000"/>
+  </cs:variation>
+  <cs:variation>
+    <a:lumMod val="50000"/>
+    <a:lumOff val="50000"/>
+  </cs:variation>
+</cs:colorStyle>
+</file>
+
+<file path=ppt/charts/style1.xml><?xml version="1.0" encoding="utf-8"?>
+<cs:chartStyle xmlns:cs="http://schemas.microsoft.com/office/drawing/2012/chartStyle" xmlns:a="http://schemas.openxmlformats.org/drawingml/2006/main" id="201">
+  <cs:axisTitle>
+    <cs:lnRef idx="0"/>
+    <cs:fillRef idx="0"/>
+    <cs:effectRef idx="0"/>
+    <cs:fontRef idx="minor">
+      <a:schemeClr val="tx1">
+        <a:lumMod val="65000"/>
+        <a:lumOff val="35000"/>
+      </a:schemeClr>
+    </cs:fontRef>
+    <cs:defRPr sz="1330" kern="1200"/>
+  </cs:axisTitle>
+  <cs:categoryAxis>
+    <cs:lnRef idx="0"/>
+    <cs:fillRef idx="0"/>
+    <cs:effectRef idx="0"/>
+    <cs:fontRef idx="minor">
+      <a:schemeClr val="tx1">
+        <a:lumMod val="65000"/>
+        <a:lumOff val="35000"/>
+      </a:schemeClr>
+    </cs:fontRef>
+    <cs:spPr>
+      <a:ln w="9525" cap="flat" cmpd="sng" algn="ctr">
+        <a:solidFill>
+          <a:schemeClr val="tx1">
+            <a:lumMod val="15000"/>
+            <a:lumOff val="85000"/>
+          </a:schemeClr>
+        </a:solidFill>
+        <a:round/>
+      </a:ln>
+    </cs:spPr>
+    <cs:defRPr sz="1197" kern="1200"/>
+  </cs:categoryAxis>
+  <cs:chartArea mods="allowNoFillOverride allowNoLineOverride">
+    <cs:lnRef idx="0"/>
+    <cs:fillRef idx="0"/>
+    <cs:effectRef idx="0"/>
+    <cs:fontRef idx="minor">
+      <a:schemeClr val="tx1"/>
+    </cs:fontRef>
+    <cs:spPr>
+      <a:solidFill>
+        <a:schemeClr val="bg1"/>
+      </a:solidFill>
+      <a:ln w="9525" cap="flat" cmpd="sng" algn="ctr">
+        <a:solidFill>
+          <a:schemeClr val="tx1">
+            <a:lumMod val="15000"/>
+            <a:lumOff val="85000"/>
+          </a:schemeClr>
+        </a:solidFill>
+        <a:round/>
+      </a:ln>
+    </cs:spPr>
+    <cs:defRPr sz="1330" kern="1200"/>
+  </cs:chartArea>
+  <cs:dataLabel>
+    <cs:lnRef idx="0"/>
+    <cs:fillRef idx="0"/>
+    <cs:effectRef idx="0"/>
+    <cs:fontRef idx="minor">
+      <a:schemeClr val="tx1">
+        <a:lumMod val="75000"/>
+        <a:lumOff val="25000"/>
+      </a:schemeClr>
+    </cs:fontRef>
+    <cs:defRPr sz="1197" kern="1200"/>
+  </cs:dataLabel>
+  <cs:dataLabelCallout>
+    <cs:lnRef idx="0"/>
+    <cs:fillRef idx="0"/>
+    <cs:effectRef idx="0"/>
+    <cs:fontRef idx="minor">
+      <a:schemeClr val="dk1">
+        <a:lumMod val="65000"/>
+        <a:lumOff val="35000"/>
+      </a:schemeClr>
+    </cs:fontRef>
+    <cs:spPr>
+      <a:solidFill>
+        <a:schemeClr val="lt1"/>
+      </a:solidFill>
+      <a:ln>
+        <a:solidFill>
+          <a:schemeClr val="dk1">
+            <a:lumMod val="25000"/>
+            <a:lumOff val="75000"/>
+          </a:schemeClr>
+        </a:solidFill>
+      </a:ln>
+    </cs:spPr>
+    <cs:defRPr sz="1197" kern="1200"/>
+    <cs:bodyPr rot="0" spcFirstLastPara="1" vertOverflow="clip" horzOverflow="clip" vert="horz" wrap="square" lIns="36576" tIns="18288" rIns="36576" bIns="18288" anchor="ctr" anchorCtr="1">
+      <a:spAutoFit/>
+    </cs:bodyPr>
+  </cs:dataLabelCallout>
+  <cs:dataPoint>
+    <cs:lnRef idx="0"/>
+    <cs:fillRef idx="1">
+      <cs:styleClr val="auto"/>
+    </cs:fillRef>
+    <cs:effectRef idx="0"/>
+    <cs:fontRef idx="minor">
+      <a:schemeClr val="tx1"/>
+    </cs:fontRef>
+  </cs:dataPoint>
+  <cs:dataPoint3D>
+    <cs:lnRef idx="0"/>
+    <cs:fillRef idx="1">
+      <cs:styleClr val="auto"/>
+    </cs:fillRef>
+    <cs:effectRef idx="0"/>
+    <cs:fontRef idx="minor">
+      <a:schemeClr val="tx1"/>
+    </cs:fontRef>
+  </cs:dataPoint3D>
+  <cs:dataPointLine>
+    <cs:lnRef idx="0">
+      <cs:styleClr val="auto"/>
+    </cs:lnRef>
+    <cs:fillRef idx="1"/>
+    <cs:effectRef idx="0"/>
+    <cs:fontRef idx="minor">
+      <a:schemeClr val="tx1"/>
+    </cs:fontRef>
+    <cs:spPr>
+      <a:ln w="28575" cap="rnd">
+        <a:solidFill>
+          <a:schemeClr val="phClr"/>
+        </a:solidFill>
+        <a:round/>
+      </a:ln>
+    </cs:spPr>
+  </cs:dataPointLine>
+  <cs:dataPointMarker>
+    <cs:lnRef idx="0">
+      <cs:styleClr val="auto"/>
+    </cs:lnRef>
+    <cs:fillRef idx="1">
+      <cs:styleClr val="auto"/>
+    </cs:fillRef>
+    <cs:effectRef idx="0"/>
+    <cs:fontRef idx="minor">
+      <a:schemeClr val="tx1"/>
+    </cs:fontRef>
+    <cs:spPr>
+      <a:ln w="9525">
+        <a:solidFill>
+          <a:schemeClr val="phClr"/>
+        </a:solidFill>
+      </a:ln>
+    </cs:spPr>
+  </cs:dataPointMarker>
+  <cs:dataPointMarkerLayout symbol="circle" size="5"/>
+  <cs:dataPointWireframe>
+    <cs:lnRef idx="0">
+      <cs:styleClr val="auto"/>
+    </cs:lnRef>
+    <cs:fillRef idx="1"/>
+    <cs:effectRef idx="0"/>
+    <cs:fontRef idx="minor">
+      <a:schemeClr val="tx1"/>
+    </cs:fontRef>
+    <cs:spPr>
+      <a:ln w="9525" cap="rnd">
+        <a:solidFill>
+          <a:schemeClr val="phClr"/>
+        </a:solidFill>
+        <a:round/>
+      </a:ln>
+    </cs:spPr>
+  </cs:dataPointWireframe>
+  <cs:dataTable>
+    <cs:lnRef idx="0"/>
+    <cs:fillRef idx="0"/>
+    <cs:effectRef idx="0"/>
+    <cs:fontRef idx="minor">
+      <a:schemeClr val="tx1">
+        <a:lumMod val="65000"/>
+        <a:lumOff val="35000"/>
+      </a:schemeClr>
+    </cs:fontRef>
+    <cs:spPr>
+      <a:noFill/>
+      <a:ln w="9525" cap="flat" cmpd="sng" algn="ctr">
+        <a:solidFill>
+          <a:schemeClr val="tx1">
+            <a:lumMod val="15000"/>
+            <a:lumOff val="85000"/>
+          </a:schemeClr>
+        </a:solidFill>
+        <a:round/>
+      </a:ln>
+    </cs:spPr>
+    <cs:defRPr sz="1197" kern="1200"/>
+  </cs:dataTable>
+  <cs:downBar>
+    <cs:lnRef idx="0"/>
+    <cs:fillRef idx="0"/>
+    <cs:effectRef idx="0"/>
+    <cs:fontRef idx="minor">
+      <a:schemeClr val="dk1"/>
+    </cs:fontRef>
+    <cs:spPr>
+      <a:solidFill>
+        <a:schemeClr val="dk1">
+          <a:lumMod val="65000"/>
+          <a:lumOff val="35000"/>
+        </a:schemeClr>
+      </a:solidFill>
+      <a:ln w="9525">
+        <a:solidFill>
+          <a:schemeClr val="tx1">
+            <a:lumMod val="65000"/>
+            <a:lumOff val="35000"/>
+          </a:schemeClr>
+        </a:solidFill>
+      </a:ln>
+    </cs:spPr>
+  </cs:downBar>
+  <cs:dropLine>
+    <cs:lnRef idx="0"/>
+    <cs:fillRef idx="0"/>
+    <cs:effectRef idx="0"/>
+    <cs:fontRef idx="minor">
+      <a:schemeClr val="tx1"/>
+    </cs:fontRef>
+    <cs:spPr>
+      <a:ln w="9525" cap="flat" cmpd="sng" algn="ctr">
+        <a:solidFill>
+          <a:schemeClr val="tx1">
+            <a:lumMod val="35000"/>
+            <a:lumOff val="65000"/>
+          </a:schemeClr>
+        </a:solidFill>
+        <a:round/>
+      </a:ln>
+    </cs:spPr>
+  </cs:dropLine>
+  <cs:errorBar>
+    <cs:lnRef idx="0"/>
+    <cs:fillRef idx="0"/>
+    <cs:effectRef idx="0"/>
+    <cs:fontRef idx="minor">
+      <a:schemeClr val="tx1"/>
+    </cs:fontRef>
+    <cs:spPr>
+      <a:ln w="9525" cap="flat" cmpd="sng" algn="ctr">
+        <a:solidFill>
+          <a:schemeClr val="tx1">
+            <a:lumMod val="65000"/>
+            <a:lumOff val="35000"/>
+          </a:schemeClr>
+        </a:solidFill>
+        <a:round/>
+      </a:ln>
+    </cs:spPr>
+  </cs:errorBar>
+  <cs:floor>
+    <cs:lnRef idx="0"/>
+    <cs:fillRef idx="0"/>
+    <cs:effectRef idx="0"/>
+    <cs:fontRef idx="minor">
+      <a:schemeClr val="tx1"/>
+    </cs:fontRef>
+    <cs:spPr>
+      <a:noFill/>
+      <a:ln>
+        <a:noFill/>
+      </a:ln>
+    </cs:spPr>
+  </cs:floor>
+  <cs:gridlineMajor>
+    <cs:lnRef idx="0"/>
+    <cs:fillRef idx="0"/>
+    <cs:effectRef idx="0"/>
+    <cs:fontRef idx="minor">
+      <a:schemeClr val="tx1"/>
+    </cs:fontRef>
+    <cs:spPr>
+      <a:ln w="9525" cap="flat" cmpd="sng" algn="ctr">
+        <a:solidFill>
+          <a:schemeClr val="tx1">
+            <a:lumMod val="15000"/>
+            <a:lumOff val="85000"/>
+          </a:schemeClr>
+        </a:solidFill>
+        <a:round/>
+      </a:ln>
+    </cs:spPr>
+  </cs:gridlineMajor>
+  <cs:gridlineMinor>
+    <cs:lnRef idx="0"/>
+    <cs:fillRef idx="0"/>
+    <cs:effectRef idx="0"/>
+    <cs:fontRef idx="minor">
+      <a:schemeClr val="tx1"/>
+    </cs:fontRef>
+    <cs:spPr>
+      <a:ln w="9525" cap="flat" cmpd="sng" algn="ctr">
+        <a:solidFill>
+          <a:schemeClr val="tx1">
+            <a:lumMod val="5000"/>
+            <a:lumOff val="95000"/>
+          </a:schemeClr>
+        </a:solidFill>
+        <a:round/>
+      </a:ln>
+    </cs:spPr>
+  </cs:gridlineMinor>
+  <cs:hiLoLine>
+    <cs:lnRef idx="0"/>
+    <cs:fillRef idx="0"/>
+    <cs:effectRef idx="0"/>
+    <cs:fontRef idx="minor">
+      <a:schemeClr val="tx1"/>
+    </cs:fontRef>
+    <cs:spPr>
+      <a:ln w="9525" cap="flat" cmpd="sng" algn="ctr">
+        <a:solidFill>
+          <a:schemeClr val="tx1">
+            <a:lumMod val="75000"/>
+            <a:lumOff val="25000"/>
+          </a:schemeClr>
+        </a:solidFill>
+        <a:round/>
+      </a:ln>
+    </cs:spPr>
+  </cs:hiLoLine>
+  <cs:leaderLine>
+    <cs:lnRef idx="0"/>
+    <cs:fillRef idx="0"/>
+    <cs:effectRef idx="0"/>
+    <cs:fontRef idx="minor">
+      <a:schemeClr val="tx1"/>
+    </cs:fontRef>
+    <cs:spPr>
+      <a:ln w="9525" cap="flat" cmpd="sng" algn="ctr">
+        <a:solidFill>
+          <a:schemeClr val="tx1">
+            <a:lumMod val="35000"/>
+            <a:lumOff val="65000"/>
+          </a:schemeClr>
+        </a:solidFill>
+        <a:round/>
+      </a:ln>
+    </cs:spPr>
+  </cs:leaderLine>
+  <cs:legend>
+    <cs:lnRef idx="0"/>
+    <cs:fillRef idx="0"/>
+    <cs:effectRef idx="0"/>
+    <cs:fontRef idx="minor">
+      <a:schemeClr val="tx1">
+        <a:lumMod val="65000"/>
+        <a:lumOff val="35000"/>
+      </a:schemeClr>
+    </cs:fontRef>
+    <cs:defRPr sz="1197" kern="1200"/>
+  </cs:legend>
+  <cs:plotArea mods="allowNoFillOverride allowNoLineOverride">
+    <cs:lnRef idx="0"/>
+    <cs:fillRef idx="0"/>
+    <cs:effectRef idx="0"/>
+    <cs:fontRef idx="minor">
+      <a:schemeClr val="tx1"/>
+    </cs:fontRef>
+  </cs:plotArea>
+  <cs:plotArea3D mods="allowNoFillOverride allowNoLineOverride">
+    <cs:lnRef idx="0"/>
+    <cs:fillRef idx="0"/>
+    <cs:effectRef idx="0"/>
+    <cs:fontRef idx="minor">
+      <a:schemeClr val="tx1"/>
+    </cs:fontRef>
+  </cs:plotArea3D>
+  <cs:seriesAxis>
+    <cs:lnRef idx="0"/>
+    <cs:fillRef idx="0"/>
+    <cs:effectRef idx="0"/>
+    <cs:fontRef idx="minor">
+      <a:schemeClr val="tx1">
+        <a:lumMod val="65000"/>
+        <a:lumOff val="35000"/>
+      </a:schemeClr>
+    </cs:fontRef>
+    <cs:defRPr sz="1197" kern="1200"/>
+  </cs:seriesAxis>
+  <cs:seriesLine>
+    <cs:lnRef idx="0"/>
+    <cs:fillRef idx="0"/>
+    <cs:effectRef idx="0"/>
+    <cs:fontRef idx="minor">
+      <a:schemeClr val="tx1"/>
+    </cs:fontRef>
+    <cs:spPr>
+      <a:ln w="9525" cap="flat" cmpd="sng" algn="ctr">
+        <a:solidFill>
+          <a:schemeClr val="tx1">
+            <a:lumMod val="35000"/>
+            <a:lumOff val="65000"/>
+          </a:schemeClr>
+        </a:solidFill>
+        <a:round/>
+      </a:ln>
+    </cs:spPr>
+  </cs:seriesLine>
+  <cs:title>
+    <cs:lnRef idx="0"/>
+    <cs:fillRef idx="0"/>
+    <cs:effectRef idx="0"/>
+    <cs:fontRef idx="minor">
+      <a:schemeClr val="tx1">
+        <a:lumMod val="65000"/>
+        <a:lumOff val="35000"/>
+      </a:schemeClr>
+    </cs:fontRef>
+    <cs:defRPr sz="1862" b="0" kern="1200" spc="0" baseline="0"/>
+  </cs:title>
+  <cs:trendline>
+    <cs:lnRef idx="0">
+      <cs:styleClr val="auto"/>
+    </cs:lnRef>
+    <cs:fillRef idx="0"/>
+    <cs:effectRef idx="0"/>
+    <cs:fontRef idx="minor">
+      <a:schemeClr val="tx1"/>
+    </cs:fontRef>
+    <cs:spPr>
+      <a:ln w="19050" cap="rnd">
+        <a:solidFill>
+          <a:schemeClr val="phClr"/>
+        </a:solidFill>
+        <a:prstDash val="sysDot"/>
+      </a:ln>
+    </cs:spPr>
+  </cs:trendline>
+  <cs:trendlineLabel>
+    <cs:lnRef idx="0"/>
+    <cs:fillRef idx="0"/>
+    <cs:effectRef idx="0"/>
+    <cs:fontRef idx="minor">
+      <a:schemeClr val="tx1">
+        <a:lumMod val="65000"/>
+        <a:lumOff val="35000"/>
+      </a:schemeClr>
+    </cs:fontRef>
+    <cs:defRPr sz="1197" kern="1200"/>
+  </cs:trendlineLabel>
+  <cs:upBar>
+    <cs:lnRef idx="0"/>
+    <cs:fillRef idx="0"/>
+    <cs:effectRef idx="0"/>
+    <cs:fontRef idx="minor">
+      <a:schemeClr val="dk1"/>
+    </cs:fontRef>
+    <cs:spPr>
+      <a:solidFill>
+        <a:schemeClr val="lt1"/>
+      </a:solidFill>
+      <a:ln w="9525">
+        <a:solidFill>
+          <a:schemeClr val="tx1">
+            <a:lumMod val="15000"/>
+            <a:lumOff val="85000"/>
+          </a:schemeClr>
+        </a:solidFill>
+      </a:ln>
+    </cs:spPr>
+  </cs:upBar>
+  <cs:valueAxis>
+    <cs:lnRef idx="0"/>
+    <cs:fillRef idx="0"/>
+    <cs:effectRef idx="0"/>
+    <cs:fontRef idx="minor">
+      <a:schemeClr val="tx1">
+        <a:lumMod val="65000"/>
+        <a:lumOff val="35000"/>
+      </a:schemeClr>
+    </cs:fontRef>
+    <cs:defRPr sz="1197" kern="1200"/>
+  </cs:valueAxis>
+  <cs:wall>
+    <cs:lnRef idx="0"/>
+    <cs:fillRef idx="0"/>
+    <cs:effectRef idx="0"/>
+    <cs:fontRef idx="minor">
+      <a:schemeClr val="tx1"/>
+    </cs:fontRef>
+    <cs:spPr>
+      <a:noFill/>
+      <a:ln>
+        <a:noFill/>
+      </a:ln>
+    </cs:spPr>
+  </cs:wall>
+</cs:chartStyle>
 </file>
 
 <file path=ppt/notesMasters/notesMaster1.xml><?xml version="1.0" encoding="utf-8"?>
@@ -195,6 +1201,7 @@
           <a:p>
             <a:fld id="{0F89C1C7-3DCD-1040-A9CF-14679D8B5DDD}" type="datetimeFigureOut">
               <a:rPr lang="en-US" smtClean="0"/>
+              <a:t>4/16/26</a:t>
             </a:fld>
             <a:endParaRPr lang="en-US"/>
           </a:p>
@@ -258,42 +1265,37 @@
           <a:p>
             <a:pPr lvl="0"/>
             <a:r>
-              <a:rPr lang="en-US" smtClean="0"/>
+              <a:rPr lang="en-US"/>
               <a:t>Click to edit Master text styles</a:t>
             </a:r>
-            <a:endParaRPr lang="en-US" smtClean="0"/>
           </a:p>
           <a:p>
             <a:pPr lvl="1"/>
             <a:r>
-              <a:rPr lang="en-US" smtClean="0"/>
+              <a:rPr lang="en-US"/>
               <a:t>Second level</a:t>
             </a:r>
-            <a:endParaRPr lang="en-US" smtClean="0"/>
           </a:p>
           <a:p>
             <a:pPr lvl="2"/>
             <a:r>
-              <a:rPr lang="en-US" smtClean="0"/>
+              <a:rPr lang="en-US"/>
               <a:t>Third level</a:t>
             </a:r>
-            <a:endParaRPr lang="en-US" smtClean="0"/>
           </a:p>
           <a:p>
             <a:pPr lvl="3"/>
             <a:r>
-              <a:rPr lang="en-US" smtClean="0"/>
+              <a:rPr lang="en-US"/>
               <a:t>Fourth level</a:t>
             </a:r>
-            <a:endParaRPr lang="en-US" smtClean="0"/>
           </a:p>
           <a:p>
             <a:pPr lvl="4"/>
             <a:r>
-              <a:rPr lang="en-US" smtClean="0"/>
+              <a:rPr lang="en-US"/>
               <a:t>Fifth level</a:t>
             </a:r>
-            <a:endParaRPr lang="en-US"/>
           </a:p>
         </p:txBody>
       </p:sp>
@@ -357,6 +1359,7 @@
           <a:p>
             <a:fld id="{BB5E49A5-4136-284D-997B-48E1D791AD67}" type="slidenum">
               <a:rPr lang="en-US" smtClean="0"/>
+              <a:t>‹#›</a:t>
             </a:fld>
             <a:endParaRPr lang="en-US"/>
           </a:p>
@@ -481,7 +1484,7 @@
         <p:nvSpPr>
           <p:cNvPr id="2" name="Slide Image Placeholder 1"/>
           <p:cNvSpPr>
-            <a:spLocks noGrp="1"/>
+            <a:spLocks noGrp="1" noRot="1" noChangeAspect="1"/>
           </p:cNvSpPr>
           <p:nvPr>
             <p:ph type="sldImg" idx="2"/>
@@ -551,7 +1554,7 @@
         <p:nvSpPr>
           <p:cNvPr id="2" name="Slide Image Placeholder 1"/>
           <p:cNvSpPr>
-            <a:spLocks noGrp="1"/>
+            <a:spLocks noGrp="1" noRot="1" noChangeAspect="1"/>
           </p:cNvSpPr>
           <p:nvPr>
             <p:ph type="sldImg" idx="2"/>
@@ -736,6 +1739,7 @@
           <a:p>
             <a:fld id="{376CE277-F64F-CD4D-8092-A1FBD0226130}" type="datetimeFigureOut">
               <a:rPr lang="en-US" smtClean="0"/>
+              <a:t>4/16/26</a:t>
             </a:fld>
             <a:endParaRPr lang="en-US"/>
           </a:p>
@@ -777,6 +1781,7 @@
           <a:p>
             <a:fld id="{0107FE2D-0FD9-7D4B-A5A0-7E9AAE6B67D1}" type="slidenum">
               <a:rPr lang="en-US" smtClean="0"/>
+              <a:t>‹#›</a:t>
             </a:fld>
             <a:endParaRPr lang="en-US"/>
           </a:p>
@@ -850,7 +1855,6 @@
               <a:rPr lang="en-GB"/>
               <a:t>Click to edit Master text styles</a:t>
             </a:r>
-            <a:endParaRPr lang="en-GB"/>
           </a:p>
           <a:p>
             <a:pPr lvl="1"/>
@@ -858,7 +1862,6 @@
               <a:rPr lang="en-GB"/>
               <a:t>Second level</a:t>
             </a:r>
-            <a:endParaRPr lang="en-GB"/>
           </a:p>
           <a:p>
             <a:pPr lvl="2"/>
@@ -866,7 +1869,6 @@
               <a:rPr lang="en-GB"/>
               <a:t>Third level</a:t>
             </a:r>
-            <a:endParaRPr lang="en-GB"/>
           </a:p>
           <a:p>
             <a:pPr lvl="3"/>
@@ -874,7 +1876,6 @@
               <a:rPr lang="en-GB"/>
               <a:t>Fourth level</a:t>
             </a:r>
-            <a:endParaRPr lang="en-GB"/>
           </a:p>
           <a:p>
             <a:pPr lvl="4"/>
@@ -903,6 +1904,7 @@
           <a:p>
             <a:fld id="{376CE277-F64F-CD4D-8092-A1FBD0226130}" type="datetimeFigureOut">
               <a:rPr lang="en-US" smtClean="0"/>
+              <a:t>4/16/26</a:t>
             </a:fld>
             <a:endParaRPr lang="en-US"/>
           </a:p>
@@ -944,6 +1946,7 @@
           <a:p>
             <a:fld id="{0107FE2D-0FD9-7D4B-A5A0-7E9AAE6B67D1}" type="slidenum">
               <a:rPr lang="en-US" smtClean="0"/>
+              <a:t>‹#›</a:t>
             </a:fld>
             <a:endParaRPr lang="en-US"/>
           </a:p>
@@ -1027,7 +2030,6 @@
               <a:rPr lang="en-GB"/>
               <a:t>Click to edit Master text styles</a:t>
             </a:r>
-            <a:endParaRPr lang="en-GB"/>
           </a:p>
           <a:p>
             <a:pPr lvl="1"/>
@@ -1035,7 +2037,6 @@
               <a:rPr lang="en-GB"/>
               <a:t>Second level</a:t>
             </a:r>
-            <a:endParaRPr lang="en-GB"/>
           </a:p>
           <a:p>
             <a:pPr lvl="2"/>
@@ -1043,7 +2044,6 @@
               <a:rPr lang="en-GB"/>
               <a:t>Third level</a:t>
             </a:r>
-            <a:endParaRPr lang="en-GB"/>
           </a:p>
           <a:p>
             <a:pPr lvl="3"/>
@@ -1051,7 +2051,6 @@
               <a:rPr lang="en-GB"/>
               <a:t>Fourth level</a:t>
             </a:r>
-            <a:endParaRPr lang="en-GB"/>
           </a:p>
           <a:p>
             <a:pPr lvl="4"/>
@@ -1080,6 +2079,7 @@
           <a:p>
             <a:fld id="{376CE277-F64F-CD4D-8092-A1FBD0226130}" type="datetimeFigureOut">
               <a:rPr lang="en-US" smtClean="0"/>
+              <a:t>4/16/26</a:t>
             </a:fld>
             <a:endParaRPr lang="en-US"/>
           </a:p>
@@ -1121,6 +2121,7 @@
           <a:p>
             <a:fld id="{0107FE2D-0FD9-7D4B-A5A0-7E9AAE6B67D1}" type="slidenum">
               <a:rPr lang="en-US" smtClean="0"/>
+              <a:t>‹#›</a:t>
             </a:fld>
             <a:endParaRPr lang="en-US"/>
           </a:p>
@@ -1194,7 +2195,6 @@
               <a:rPr lang="en-GB"/>
               <a:t>Click to edit Master text styles</a:t>
             </a:r>
-            <a:endParaRPr lang="en-GB"/>
           </a:p>
           <a:p>
             <a:pPr lvl="1"/>
@@ -1202,7 +2202,6 @@
               <a:rPr lang="en-GB"/>
               <a:t>Second level</a:t>
             </a:r>
-            <a:endParaRPr lang="en-GB"/>
           </a:p>
           <a:p>
             <a:pPr lvl="2"/>
@@ -1210,7 +2209,6 @@
               <a:rPr lang="en-GB"/>
               <a:t>Third level</a:t>
             </a:r>
-            <a:endParaRPr lang="en-GB"/>
           </a:p>
           <a:p>
             <a:pPr lvl="3"/>
@@ -1218,7 +2216,6 @@
               <a:rPr lang="en-GB"/>
               <a:t>Fourth level</a:t>
             </a:r>
-            <a:endParaRPr lang="en-GB"/>
           </a:p>
           <a:p>
             <a:pPr lvl="4"/>
@@ -1247,6 +2244,7 @@
           <a:p>
             <a:fld id="{376CE277-F64F-CD4D-8092-A1FBD0226130}" type="datetimeFigureOut">
               <a:rPr lang="en-US" smtClean="0"/>
+              <a:t>4/16/26</a:t>
             </a:fld>
             <a:endParaRPr lang="en-US"/>
           </a:p>
@@ -1288,6 +2286,7 @@
           <a:p>
             <a:fld id="{0107FE2D-0FD9-7D4B-A5A0-7E9AAE6B67D1}" type="slidenum">
               <a:rPr lang="en-US" smtClean="0"/>
+              <a:t>‹#›</a:t>
             </a:fld>
             <a:endParaRPr lang="en-US"/>
           </a:p>
@@ -1466,7 +2465,6 @@
               <a:rPr lang="en-GB"/>
               <a:t>Click to edit Master text styles</a:t>
             </a:r>
-            <a:endParaRPr lang="en-GB"/>
           </a:p>
         </p:txBody>
       </p:sp>
@@ -1487,6 +2485,7 @@
           <a:p>
             <a:fld id="{376CE277-F64F-CD4D-8092-A1FBD0226130}" type="datetimeFigureOut">
               <a:rPr lang="en-US" smtClean="0"/>
+              <a:t>4/16/26</a:t>
             </a:fld>
             <a:endParaRPr lang="en-US"/>
           </a:p>
@@ -1528,6 +2527,7 @@
           <a:p>
             <a:fld id="{0107FE2D-0FD9-7D4B-A5A0-7E9AAE6B67D1}" type="slidenum">
               <a:rPr lang="en-US" smtClean="0"/>
+              <a:t>‹#›</a:t>
             </a:fld>
             <a:endParaRPr lang="en-US"/>
           </a:p>
@@ -1606,7 +2606,6 @@
               <a:rPr lang="en-GB"/>
               <a:t>Click to edit Master text styles</a:t>
             </a:r>
-            <a:endParaRPr lang="en-GB"/>
           </a:p>
           <a:p>
             <a:pPr lvl="1"/>
@@ -1614,7 +2613,6 @@
               <a:rPr lang="en-GB"/>
               <a:t>Second level</a:t>
             </a:r>
-            <a:endParaRPr lang="en-GB"/>
           </a:p>
           <a:p>
             <a:pPr lvl="2"/>
@@ -1622,7 +2620,6 @@
               <a:rPr lang="en-GB"/>
               <a:t>Third level</a:t>
             </a:r>
-            <a:endParaRPr lang="en-GB"/>
           </a:p>
           <a:p>
             <a:pPr lvl="3"/>
@@ -1630,7 +2627,6 @@
               <a:rPr lang="en-GB"/>
               <a:t>Fourth level</a:t>
             </a:r>
-            <a:endParaRPr lang="en-GB"/>
           </a:p>
           <a:p>
             <a:pPr lvl="4"/>
@@ -1667,7 +2663,6 @@
               <a:rPr lang="en-GB"/>
               <a:t>Click to edit Master text styles</a:t>
             </a:r>
-            <a:endParaRPr lang="en-GB"/>
           </a:p>
           <a:p>
             <a:pPr lvl="1"/>
@@ -1675,7 +2670,6 @@
               <a:rPr lang="en-GB"/>
               <a:t>Second level</a:t>
             </a:r>
-            <a:endParaRPr lang="en-GB"/>
           </a:p>
           <a:p>
             <a:pPr lvl="2"/>
@@ -1683,7 +2677,6 @@
               <a:rPr lang="en-GB"/>
               <a:t>Third level</a:t>
             </a:r>
-            <a:endParaRPr lang="en-GB"/>
           </a:p>
           <a:p>
             <a:pPr lvl="3"/>
@@ -1691,7 +2684,6 @@
               <a:rPr lang="en-GB"/>
               <a:t>Fourth level</a:t>
             </a:r>
-            <a:endParaRPr lang="en-GB"/>
           </a:p>
           <a:p>
             <a:pPr lvl="4"/>
@@ -1720,6 +2712,7 @@
           <a:p>
             <a:fld id="{376CE277-F64F-CD4D-8092-A1FBD0226130}" type="datetimeFigureOut">
               <a:rPr lang="en-US" smtClean="0"/>
+              <a:t>4/16/26</a:t>
             </a:fld>
             <a:endParaRPr lang="en-US"/>
           </a:p>
@@ -1761,6 +2754,7 @@
           <a:p>
             <a:fld id="{0107FE2D-0FD9-7D4B-A5A0-7E9AAE6B67D1}" type="slidenum">
               <a:rPr lang="en-US" smtClean="0"/>
+              <a:t>‹#›</a:t>
             </a:fld>
             <a:endParaRPr lang="en-US"/>
           </a:p>
@@ -1881,7 +2875,6 @@
               <a:rPr lang="en-GB"/>
               <a:t>Click to edit Master text styles</a:t>
             </a:r>
-            <a:endParaRPr lang="en-GB"/>
           </a:p>
         </p:txBody>
       </p:sp>
@@ -1910,7 +2903,6 @@
               <a:rPr lang="en-GB"/>
               <a:t>Click to edit Master text styles</a:t>
             </a:r>
-            <a:endParaRPr lang="en-GB"/>
           </a:p>
           <a:p>
             <a:pPr lvl="1"/>
@@ -1918,7 +2910,6 @@
               <a:rPr lang="en-GB"/>
               <a:t>Second level</a:t>
             </a:r>
-            <a:endParaRPr lang="en-GB"/>
           </a:p>
           <a:p>
             <a:pPr lvl="2"/>
@@ -1926,7 +2917,6 @@
               <a:rPr lang="en-GB"/>
               <a:t>Third level</a:t>
             </a:r>
-            <a:endParaRPr lang="en-GB"/>
           </a:p>
           <a:p>
             <a:pPr lvl="3"/>
@@ -1934,7 +2924,6 @@
               <a:rPr lang="en-GB"/>
               <a:t>Fourth level</a:t>
             </a:r>
-            <a:endParaRPr lang="en-GB"/>
           </a:p>
           <a:p>
             <a:pPr lvl="4"/>
@@ -2008,7 +2997,6 @@
               <a:rPr lang="en-GB"/>
               <a:t>Click to edit Master text styles</a:t>
             </a:r>
-            <a:endParaRPr lang="en-GB"/>
           </a:p>
         </p:txBody>
       </p:sp>
@@ -2037,7 +3025,6 @@
               <a:rPr lang="en-GB"/>
               <a:t>Click to edit Master text styles</a:t>
             </a:r>
-            <a:endParaRPr lang="en-GB"/>
           </a:p>
           <a:p>
             <a:pPr lvl="1"/>
@@ -2045,7 +3032,6 @@
               <a:rPr lang="en-GB"/>
               <a:t>Second level</a:t>
             </a:r>
-            <a:endParaRPr lang="en-GB"/>
           </a:p>
           <a:p>
             <a:pPr lvl="2"/>
@@ -2053,7 +3039,6 @@
               <a:rPr lang="en-GB"/>
               <a:t>Third level</a:t>
             </a:r>
-            <a:endParaRPr lang="en-GB"/>
           </a:p>
           <a:p>
             <a:pPr lvl="3"/>
@@ -2061,7 +3046,6 @@
               <a:rPr lang="en-GB"/>
               <a:t>Fourth level</a:t>
             </a:r>
-            <a:endParaRPr lang="en-GB"/>
           </a:p>
           <a:p>
             <a:pPr lvl="4"/>
@@ -2090,6 +3074,7 @@
           <a:p>
             <a:fld id="{376CE277-F64F-CD4D-8092-A1FBD0226130}" type="datetimeFigureOut">
               <a:rPr lang="en-US" smtClean="0"/>
+              <a:t>4/16/26</a:t>
             </a:fld>
             <a:endParaRPr lang="en-US"/>
           </a:p>
@@ -2131,6 +3116,7 @@
           <a:p>
             <a:fld id="{0107FE2D-0FD9-7D4B-A5A0-7E9AAE6B67D1}" type="slidenum">
               <a:rPr lang="en-US" smtClean="0"/>
+              <a:t>‹#›</a:t>
             </a:fld>
             <a:endParaRPr lang="en-US"/>
           </a:p>
@@ -2201,6 +3187,7 @@
           <a:p>
             <a:fld id="{376CE277-F64F-CD4D-8092-A1FBD0226130}" type="datetimeFigureOut">
               <a:rPr lang="en-US" smtClean="0"/>
+              <a:t>4/16/26</a:t>
             </a:fld>
             <a:endParaRPr lang="en-US"/>
           </a:p>
@@ -2242,6 +3229,7 @@
           <a:p>
             <a:fld id="{0107FE2D-0FD9-7D4B-A5A0-7E9AAE6B67D1}" type="slidenum">
               <a:rPr lang="en-US" smtClean="0"/>
+              <a:t>‹#›</a:t>
             </a:fld>
             <a:endParaRPr lang="en-US"/>
           </a:p>
@@ -2289,6 +3277,7 @@
           <a:p>
             <a:fld id="{376CE277-F64F-CD4D-8092-A1FBD0226130}" type="datetimeFigureOut">
               <a:rPr lang="en-US" smtClean="0"/>
+              <a:t>4/16/26</a:t>
             </a:fld>
             <a:endParaRPr lang="en-US"/>
           </a:p>
@@ -2330,6 +3319,7 @@
           <a:p>
             <a:fld id="{0107FE2D-0FD9-7D4B-A5A0-7E9AAE6B67D1}" type="slidenum">
               <a:rPr lang="en-US" smtClean="0"/>
+              <a:t>‹#›</a:t>
             </a:fld>
             <a:endParaRPr lang="en-US"/>
           </a:p>
@@ -2445,7 +3435,6 @@
               <a:rPr lang="en-GB"/>
               <a:t>Click to edit Master text styles</a:t>
             </a:r>
-            <a:endParaRPr lang="en-GB"/>
           </a:p>
           <a:p>
             <a:pPr lvl="1"/>
@@ -2453,7 +3442,6 @@
               <a:rPr lang="en-GB"/>
               <a:t>Second level</a:t>
             </a:r>
-            <a:endParaRPr lang="en-GB"/>
           </a:p>
           <a:p>
             <a:pPr lvl="2"/>
@@ -2461,7 +3449,6 @@
               <a:rPr lang="en-GB"/>
               <a:t>Third level</a:t>
             </a:r>
-            <a:endParaRPr lang="en-GB"/>
           </a:p>
           <a:p>
             <a:pPr lvl="3"/>
@@ -2469,7 +3456,6 @@
               <a:rPr lang="en-GB"/>
               <a:t>Fourth level</a:t>
             </a:r>
-            <a:endParaRPr lang="en-GB"/>
           </a:p>
           <a:p>
             <a:pPr lvl="4"/>
@@ -2543,7 +3529,6 @@
               <a:rPr lang="en-GB"/>
               <a:t>Click to edit Master text styles</a:t>
             </a:r>
-            <a:endParaRPr lang="en-GB"/>
           </a:p>
         </p:txBody>
       </p:sp>
@@ -2564,6 +3549,7 @@
           <a:p>
             <a:fld id="{376CE277-F64F-CD4D-8092-A1FBD0226130}" type="datetimeFigureOut">
               <a:rPr lang="en-US" smtClean="0"/>
+              <a:t>4/16/26</a:t>
             </a:fld>
             <a:endParaRPr lang="en-US"/>
           </a:p>
@@ -2605,6 +3591,7 @@
           <a:p>
             <a:fld id="{0107FE2D-0FD9-7D4B-A5A0-7E9AAE6B67D1}" type="slidenum">
               <a:rPr lang="en-US" smtClean="0"/>
+              <a:t>‹#›</a:t>
             </a:fld>
             <a:endParaRPr lang="en-US"/>
           </a:p>
@@ -2790,7 +3777,6 @@
               <a:rPr lang="en-GB"/>
               <a:t>Click to edit Master text styles</a:t>
             </a:r>
-            <a:endParaRPr lang="en-GB"/>
           </a:p>
         </p:txBody>
       </p:sp>
@@ -2811,6 +3797,7 @@
           <a:p>
             <a:fld id="{376CE277-F64F-CD4D-8092-A1FBD0226130}" type="datetimeFigureOut">
               <a:rPr lang="en-US" smtClean="0"/>
+              <a:t>4/16/26</a:t>
             </a:fld>
             <a:endParaRPr lang="en-US"/>
           </a:p>
@@ -2852,6 +3839,7 @@
           <a:p>
             <a:fld id="{0107FE2D-0FD9-7D4B-A5A0-7E9AAE6B67D1}" type="slidenum">
               <a:rPr lang="en-US" smtClean="0"/>
+              <a:t>‹#›</a:t>
             </a:fld>
             <a:endParaRPr lang="en-US"/>
           </a:p>
@@ -2950,7 +3938,6 @@
               <a:rPr lang="en-GB"/>
               <a:t>Click to edit Master text styles</a:t>
             </a:r>
-            <a:endParaRPr lang="en-GB"/>
           </a:p>
           <a:p>
             <a:pPr lvl="1"/>
@@ -2958,7 +3945,6 @@
               <a:rPr lang="en-GB"/>
               <a:t>Second level</a:t>
             </a:r>
-            <a:endParaRPr lang="en-GB"/>
           </a:p>
           <a:p>
             <a:pPr lvl="2"/>
@@ -2966,7 +3952,6 @@
               <a:rPr lang="en-GB"/>
               <a:t>Third level</a:t>
             </a:r>
-            <a:endParaRPr lang="en-GB"/>
           </a:p>
           <a:p>
             <a:pPr lvl="3"/>
@@ -2974,7 +3959,6 @@
               <a:rPr lang="en-GB"/>
               <a:t>Fourth level</a:t>
             </a:r>
-            <a:endParaRPr lang="en-GB"/>
           </a:p>
           <a:p>
             <a:pPr lvl="4"/>
@@ -3021,6 +4005,7 @@
           <a:p>
             <a:fld id="{376CE277-F64F-CD4D-8092-A1FBD0226130}" type="datetimeFigureOut">
               <a:rPr lang="en-US" smtClean="0"/>
+              <a:t>4/16/26</a:t>
             </a:fld>
             <a:endParaRPr lang="en-US"/>
           </a:p>
@@ -3098,6 +4083,7 @@
           <a:p>
             <a:fld id="{0107FE2D-0FD9-7D4B-A5A0-7E9AAE6B67D1}" type="slidenum">
               <a:rPr lang="en-US" smtClean="0"/>
+              <a:t>‹#›</a:t>
             </a:fld>
             <a:endParaRPr lang="en-US"/>
           </a:p>
@@ -3443,7 +4429,6 @@
               <a:rPr lang="en-US" dirty="0"/>
               <a:t>Test Table Slide</a:t>
             </a:r>
-            <a:endParaRPr lang="en-US" dirty="0"/>
           </a:p>
         </p:txBody>
       </p:sp>
@@ -3471,7 +4456,6 @@
               <a:rPr lang="en-US" dirty="0"/>
               <a:t>With footnote</a:t>
             </a:r>
-            <a:endParaRPr lang="en-US" dirty="0"/>
           </a:p>
         </p:txBody>
       </p:sp>
@@ -3494,13 +4478,55 @@
                 <a:tableStyleId>{5C22544A-7EE6-4342-B048-85BDC9FD1C3A}</a:tableStyleId>
               </a:tblPr>
               <a:tblGrid>
-                <a:gridCol w="1161143"/>
-                <a:gridCol w="1161143"/>
-                <a:gridCol w="1161143"/>
-                <a:gridCol w="1161143"/>
-                <a:gridCol w="1161143"/>
-                <a:gridCol w="1161143"/>
-                <a:gridCol w="1161143"/>
+                <a:gridCol w="1161143">
+                  <a:extLst>
+                    <a:ext uri="{9D8B030D-6E8A-4147-A177-3AD203B41FA5}">
+                      <a16:colId xmlns:a16="http://schemas.microsoft.com/office/drawing/2014/main" val="20000"/>
+                    </a:ext>
+                  </a:extLst>
+                </a:gridCol>
+                <a:gridCol w="1161143">
+                  <a:extLst>
+                    <a:ext uri="{9D8B030D-6E8A-4147-A177-3AD203B41FA5}">
+                      <a16:colId xmlns:a16="http://schemas.microsoft.com/office/drawing/2014/main" val="20001"/>
+                    </a:ext>
+                  </a:extLst>
+                </a:gridCol>
+                <a:gridCol w="1161143">
+                  <a:extLst>
+                    <a:ext uri="{9D8B030D-6E8A-4147-A177-3AD203B41FA5}">
+                      <a16:colId xmlns:a16="http://schemas.microsoft.com/office/drawing/2014/main" val="20002"/>
+                    </a:ext>
+                  </a:extLst>
+                </a:gridCol>
+                <a:gridCol w="1161143">
+                  <a:extLst>
+                    <a:ext uri="{9D8B030D-6E8A-4147-A177-3AD203B41FA5}">
+                      <a16:colId xmlns:a16="http://schemas.microsoft.com/office/drawing/2014/main" val="20003"/>
+                    </a:ext>
+                  </a:extLst>
+                </a:gridCol>
+                <a:gridCol w="1161143">
+                  <a:extLst>
+                    <a:ext uri="{9D8B030D-6E8A-4147-A177-3AD203B41FA5}">
+                      <a16:colId xmlns:a16="http://schemas.microsoft.com/office/drawing/2014/main" val="20004"/>
+                    </a:ext>
+                  </a:extLst>
+                </a:gridCol>
+                <a:gridCol w="1161143">
+                  <a:extLst>
+                    <a:ext uri="{9D8B030D-6E8A-4147-A177-3AD203B41FA5}">
+                      <a16:colId xmlns:a16="http://schemas.microsoft.com/office/drawing/2014/main" val="20005"/>
+                    </a:ext>
+                  </a:extLst>
+                </a:gridCol>
+                <a:gridCol w="1161143">
+                  <a:extLst>
+                    <a:ext uri="{9D8B030D-6E8A-4147-A177-3AD203B41FA5}">
+                      <a16:colId xmlns:a16="http://schemas.microsoft.com/office/drawing/2014/main" val="20006"/>
+                    </a:ext>
+                  </a:extLst>
+                </a:gridCol>
               </a:tblGrid>
               <a:tr h="370840">
                 <a:tc>
@@ -3522,15 +4548,28 @@
                         <a:rPr lang="en-US" dirty="0"/>
                         <a:t>Class1</a:t>
                       </a:r>
-                      <a:endParaRPr lang="en-US" dirty="0"/>
                     </a:p>
                   </a:txBody>
                   <a:tcPr/>
                 </a:tc>
                 <a:tc hMerge="1">
+                  <a:txBody>
+                    <a:bodyPr/>
+                    <a:lstStyle/>
+                    <a:p>
+                      <a:endParaRPr lang="zh-CN"/>
+                    </a:p>
+                  </a:txBody>
                   <a:tcPr/>
                 </a:tc>
                 <a:tc hMerge="1">
+                  <a:txBody>
+                    <a:bodyPr/>
+                    <a:lstStyle/>
+                    <a:p>
+                      <a:endParaRPr lang="zh-CN"/>
+                    </a:p>
+                  </a:txBody>
                   <a:tcPr/>
                 </a:tc>
                 <a:tc gridSpan="3">
@@ -3542,17 +4581,35 @@
                         <a:rPr lang="en-US" dirty="0"/>
                         <a:t>Class2</a:t>
                       </a:r>
-                      <a:endParaRPr lang="en-US" dirty="0"/>
                     </a:p>
                   </a:txBody>
                   <a:tcPr/>
                 </a:tc>
                 <a:tc hMerge="1">
+                  <a:txBody>
+                    <a:bodyPr/>
+                    <a:lstStyle/>
+                    <a:p>
+                      <a:endParaRPr lang="zh-CN"/>
+                    </a:p>
+                  </a:txBody>
                   <a:tcPr/>
                 </a:tc>
                 <a:tc hMerge="1">
+                  <a:txBody>
+                    <a:bodyPr/>
+                    <a:lstStyle/>
+                    <a:p>
+                      <a:endParaRPr lang="zh-CN"/>
+                    </a:p>
+                  </a:txBody>
                   <a:tcPr/>
                 </a:tc>
+                <a:extLst>
+                  <a:ext uri="{0D108BD9-81ED-4DB2-BD59-A6C34878D82A}">
+                    <a16:rowId xmlns:a16="http://schemas.microsoft.com/office/drawing/2014/main" val="10000"/>
+                  </a:ext>
+                </a:extLst>
               </a:tr>
               <a:tr h="370840">
                 <a:tc>
@@ -3580,6 +4637,13 @@
                   <a:tcPr/>
                 </a:tc>
                 <a:tc hMerge="1">
+                  <a:txBody>
+                    <a:bodyPr/>
+                    <a:lstStyle/>
+                    <a:p>
+                      <a:endParaRPr lang="zh-CN"/>
+                    </a:p>
+                  </a:txBody>
                   <a:tcPr/>
                 </a:tc>
                 <a:tc>
@@ -3591,7 +4655,6 @@
                         <a:rPr lang="en-US" dirty="0"/>
                         <a:t>C</a:t>
                       </a:r>
-                      <a:endParaRPr lang="en-US" dirty="0"/>
                     </a:p>
                   </a:txBody>
                   <a:tcPr/>
@@ -3605,7 +4668,6 @@
                         <a:rPr lang="en-US" dirty="0"/>
                         <a:t>A</a:t>
                       </a:r>
-                      <a:endParaRPr lang="en-US" dirty="0"/>
                     </a:p>
                   </a:txBody>
                   <a:tcPr/>
@@ -3619,7 +4681,6 @@
                         <a:rPr lang="en-US" dirty="0"/>
                         <a:t>B</a:t>
                       </a:r>
-                      <a:endParaRPr lang="en-US" dirty="0"/>
                     </a:p>
                   </a:txBody>
                   <a:tcPr/>
@@ -3633,11 +4694,15 @@
                         <a:rPr lang="en-US" dirty="0"/>
                         <a:t>C</a:t>
                       </a:r>
-                      <a:endParaRPr lang="en-US" dirty="0"/>
                     </a:p>
                   </a:txBody>
                   <a:tcPr/>
                 </a:tc>
+                <a:extLst>
+                  <a:ext uri="{0D108BD9-81ED-4DB2-BD59-A6C34878D82A}">
+                    <a16:rowId xmlns:a16="http://schemas.microsoft.com/office/drawing/2014/main" val="10001"/>
+                  </a:ext>
+                </a:extLst>
               </a:tr>
               <a:tr h="370840">
                 <a:tc>
@@ -3649,7 +4714,6 @@
                         <a:rPr lang="en-US" dirty="0"/>
                         <a:t>R1</a:t>
                       </a:r>
-                      <a:endParaRPr lang="en-US" dirty="0"/>
                     </a:p>
                   </a:txBody>
                   <a:tcPr/>
@@ -3663,7 +4727,6 @@
                         <a:rPr lang="en-US" dirty="0"/>
                         <a:t>True</a:t>
                       </a:r>
-                      <a:endParaRPr lang="en-US" dirty="0"/>
                     </a:p>
                   </a:txBody>
                   <a:tcPr/>
@@ -3677,7 +4740,6 @@
                         <a:rPr lang="en-US" dirty="0"/>
                         <a:t>False</a:t>
                       </a:r>
-                      <a:endParaRPr lang="en-US" dirty="0"/>
                     </a:p>
                   </a:txBody>
                   <a:tcPr/>
@@ -3701,7 +4763,6 @@
                         <a:rPr lang="en-US" dirty="0"/>
                         <a:t>False</a:t>
                       </a:r>
-                      <a:endParaRPr lang="en-US" dirty="0"/>
                     </a:p>
                   </a:txBody>
                   <a:tcPr/>
@@ -3715,7 +4776,6 @@
                         <a:rPr lang="en-US" dirty="0"/>
                         <a:t>True</a:t>
                       </a:r>
-                      <a:endParaRPr lang="en-US" dirty="0"/>
                     </a:p>
                   </a:txBody>
                   <a:tcPr/>
@@ -3729,11 +4789,15 @@
                         <a:rPr lang="en-US" dirty="0"/>
                         <a:t>True</a:t>
                       </a:r>
-                      <a:endParaRPr lang="en-US" dirty="0"/>
                     </a:p>
                   </a:txBody>
                   <a:tcPr/>
                 </a:tc>
+                <a:extLst>
+                  <a:ext uri="{0D108BD9-81ED-4DB2-BD59-A6C34878D82A}">
+                    <a16:rowId xmlns:a16="http://schemas.microsoft.com/office/drawing/2014/main" val="10002"/>
+                  </a:ext>
+                </a:extLst>
               </a:tr>
               <a:tr h="370840">
                 <a:tc>
@@ -3745,7 +4809,6 @@
                         <a:rPr lang="en-US" dirty="0"/>
                         <a:t>R2</a:t>
                       </a:r>
-                      <a:endParaRPr lang="en-US" dirty="0"/>
                     </a:p>
                   </a:txBody>
                   <a:tcPr/>
@@ -3779,7 +4842,6 @@
                         <a:rPr lang="en-US" dirty="0"/>
                         <a:t>True</a:t>
                       </a:r>
-                      <a:endParaRPr lang="en-US" dirty="0"/>
                     </a:p>
                   </a:txBody>
                   <a:tcPr/>
@@ -3793,7 +4855,6 @@
                         <a:rPr lang="en-US" dirty="0"/>
                         <a:t>False</a:t>
                       </a:r>
-                      <a:endParaRPr lang="en-US" dirty="0"/>
                     </a:p>
                   </a:txBody>
                   <a:tcPr/>
@@ -3818,6 +4879,11 @@
                   </a:txBody>
                   <a:tcPr/>
                 </a:tc>
+                <a:extLst>
+                  <a:ext uri="{0D108BD9-81ED-4DB2-BD59-A6C34878D82A}">
+                    <a16:rowId xmlns:a16="http://schemas.microsoft.com/office/drawing/2014/main" val="10003"/>
+                  </a:ext>
+                </a:extLst>
               </a:tr>
               <a:tr h="370840">
                 <a:tc rowSpan="2">
@@ -3829,7 +4895,6 @@
                         <a:rPr lang="en-US" dirty="0"/>
                         <a:t>R3</a:t>
                       </a:r>
-                      <a:endParaRPr lang="en-US" dirty="0"/>
                     </a:p>
                   </a:txBody>
                   <a:tcPr/>
@@ -3843,7 +4908,6 @@
                         <a:rPr lang="en-US" dirty="0"/>
                         <a:t>False</a:t>
                       </a:r>
-                      <a:endParaRPr lang="en-US" dirty="0"/>
                     </a:p>
                   </a:txBody>
                   <a:tcPr/>
@@ -3887,7 +4951,6 @@
                         <a:rPr lang="en-US" dirty="0"/>
                         <a:t>False</a:t>
                       </a:r>
-                      <a:endParaRPr lang="en-US" dirty="0"/>
                     </a:p>
                   </a:txBody>
                   <a:tcPr/>
@@ -3902,31 +4965,19 @@
                   </a:txBody>
                   <a:tcPr/>
                 </a:tc>
+                <a:extLst>
+                  <a:ext uri="{0D108BD9-81ED-4DB2-BD59-A6C34878D82A}">
+                    <a16:rowId xmlns:a16="http://schemas.microsoft.com/office/drawing/2014/main" val="10004"/>
+                  </a:ext>
+                </a:extLst>
               </a:tr>
               <a:tr h="370840">
                 <a:tc vMerge="1">
-                  <a:tcPr/>
-                </a:tc>
-                <a:tc>
                   <a:txBody>
                     <a:bodyPr/>
                     <a:lstStyle/>
                     <a:p>
-                      <a:endParaRPr lang="en-US" dirty="0"/>
-                    </a:p>
-                  </a:txBody>
-                  <a:tcPr/>
-                </a:tc>
-                <a:tc>
-                  <a:txBody>
-                    <a:bodyPr/>
-                    <a:lstStyle/>
-                    <a:p>
-                      <a:r>
-                        <a:rPr lang="en-US" dirty="0"/>
-                        <a:t>True</a:t>
-                      </a:r>
-                      <a:endParaRPr lang="en-US" dirty="0"/>
+                      <a:endParaRPr lang="zh-CN"/>
                     </a:p>
                   </a:txBody>
                   <a:tcPr/>
@@ -3950,7 +5001,29 @@
                         <a:rPr lang="en-US" dirty="0"/>
                         <a:t>True</a:t>
                       </a:r>
+                    </a:p>
+                  </a:txBody>
+                  <a:tcPr/>
+                </a:tc>
+                <a:tc>
+                  <a:txBody>
+                    <a:bodyPr/>
+                    <a:lstStyle/>
+                    <a:p>
                       <a:endParaRPr lang="en-US" dirty="0"/>
+                    </a:p>
+                  </a:txBody>
+                  <a:tcPr/>
+                </a:tc>
+                <a:tc>
+                  <a:txBody>
+                    <a:bodyPr/>
+                    <a:lstStyle/>
+                    <a:p>
+                      <a:r>
+                        <a:rPr lang="en-US" dirty="0"/>
+                        <a:t>True</a:t>
+                      </a:r>
                     </a:p>
                   </a:txBody>
                   <a:tcPr/>
@@ -3975,6 +5048,11 @@
                   </a:txBody>
                   <a:tcPr/>
                 </a:tc>
+                <a:extLst>
+                  <a:ext uri="{0D108BD9-81ED-4DB2-BD59-A6C34878D82A}">
+                    <a16:rowId xmlns:a16="http://schemas.microsoft.com/office/drawing/2014/main" val="10005"/>
+                  </a:ext>
+                </a:extLst>
               </a:tr>
               <a:tr h="370840">
                 <a:tc rowSpan="3">
@@ -3986,7 +5064,6 @@
                         <a:rPr lang="en-US" dirty="0"/>
                         <a:t>R4</a:t>
                       </a:r>
-                      <a:endParaRPr lang="en-US" dirty="0"/>
                     </a:p>
                   </a:txBody>
                   <a:tcPr/>
@@ -4020,7 +5097,6 @@
                         <a:rPr lang="en-US" dirty="0"/>
                         <a:t>False</a:t>
                       </a:r>
-                      <a:endParaRPr lang="en-US" dirty="0"/>
                     </a:p>
                   </a:txBody>
                   <a:tcPr/>
@@ -4044,7 +5120,6 @@
                         <a:rPr lang="en-US" dirty="0"/>
                         <a:t>False</a:t>
                       </a:r>
-                      <a:endParaRPr lang="en-US" dirty="0"/>
                     </a:p>
                   </a:txBody>
                   <a:tcPr/>
@@ -4059,31 +5134,19 @@
                   </a:txBody>
                   <a:tcPr/>
                 </a:tc>
+                <a:extLst>
+                  <a:ext uri="{0D108BD9-81ED-4DB2-BD59-A6C34878D82A}">
+                    <a16:rowId xmlns:a16="http://schemas.microsoft.com/office/drawing/2014/main" val="10006"/>
+                  </a:ext>
+                </a:extLst>
               </a:tr>
               <a:tr h="370840">
                 <a:tc vMerge="1">
-                  <a:tcPr/>
-                </a:tc>
-                <a:tc>
                   <a:txBody>
                     <a:bodyPr/>
                     <a:lstStyle/>
                     <a:p>
-                      <a:endParaRPr lang="en-US" dirty="0"/>
-                    </a:p>
-                  </a:txBody>
-                  <a:tcPr/>
-                </a:tc>
-                <a:tc>
-                  <a:txBody>
-                    <a:bodyPr/>
-                    <a:lstStyle/>
-                    <a:p>
-                      <a:r>
-                        <a:rPr lang="en-US" dirty="0"/>
-                        <a:t>True</a:t>
-                      </a:r>
-                      <a:endParaRPr lang="en-US" dirty="0"/>
+                      <a:endParaRPr lang="zh-CN"/>
                     </a:p>
                   </a:txBody>
                   <a:tcPr/>
@@ -4107,7 +5170,6 @@
                         <a:rPr lang="en-US" dirty="0"/>
                         <a:t>True</a:t>
                       </a:r>
-                      <a:endParaRPr lang="en-US" dirty="0"/>
                     </a:p>
                   </a:txBody>
                   <a:tcPr/>
@@ -4117,57 +5179,6 @@
                     <a:bodyPr/>
                     <a:lstStyle/>
                     <a:p>
-                      <a:r>
-                        <a:rPr lang="en-US" dirty="0"/>
-                        <a:t>False</a:t>
-                      </a:r>
-                      <a:endParaRPr lang="en-US" dirty="0"/>
-                    </a:p>
-                  </a:txBody>
-                  <a:tcPr/>
-                </a:tc>
-                <a:tc>
-                  <a:txBody>
-                    <a:bodyPr/>
-                    <a:lstStyle/>
-                    <a:p>
-                      <a:r>
-                        <a:rPr lang="en-US" dirty="0"/>
-                        <a:t>False</a:t>
-                      </a:r>
-                      <a:endParaRPr lang="en-US" dirty="0"/>
-                    </a:p>
-                  </a:txBody>
-                  <a:tcPr/>
-                </a:tc>
-              </a:tr>
-              <a:tr h="370840">
-                <a:tc vMerge="1">
-                  <a:tcPr/>
-                </a:tc>
-                <a:tc>
-                  <a:txBody>
-                    <a:bodyPr/>
-                    <a:lstStyle/>
-                    <a:p>
-                      <a:r>
-                        <a:rPr lang="en-US" dirty="0"/>
-                        <a:t>True</a:t>
-                      </a:r>
-                      <a:endParaRPr lang="en-US" dirty="0"/>
-                    </a:p>
-                  </a:txBody>
-                  <a:tcPr/>
-                </a:tc>
-                <a:tc>
-                  <a:txBody>
-                    <a:bodyPr/>
-                    <a:lstStyle/>
-                    <a:p>
-                      <a:r>
-                        <a:rPr lang="en-US" dirty="0"/>
-                        <a:t>False</a:t>
-                      </a:r>
                       <a:endParaRPr lang="en-US" dirty="0"/>
                     </a:p>
                   </a:txBody>
@@ -4182,7 +5193,6 @@
                         <a:rPr lang="en-US" dirty="0"/>
                         <a:t>True</a:t>
                       </a:r>
-                      <a:endParaRPr lang="en-US" dirty="0"/>
                     </a:p>
                   </a:txBody>
                   <a:tcPr/>
@@ -4196,7 +5206,36 @@
                         <a:rPr lang="en-US" dirty="0"/>
                         <a:t>False</a:t>
                       </a:r>
-                      <a:endParaRPr lang="en-US" dirty="0"/>
+                    </a:p>
+                  </a:txBody>
+                  <a:tcPr/>
+                </a:tc>
+                <a:tc>
+                  <a:txBody>
+                    <a:bodyPr/>
+                    <a:lstStyle/>
+                    <a:p>
+                      <a:r>
+                        <a:rPr lang="en-US" dirty="0"/>
+                        <a:t>False</a:t>
+                      </a:r>
+                    </a:p>
+                  </a:txBody>
+                  <a:tcPr/>
+                </a:tc>
+                <a:extLst>
+                  <a:ext uri="{0D108BD9-81ED-4DB2-BD59-A6C34878D82A}">
+                    <a16:rowId xmlns:a16="http://schemas.microsoft.com/office/drawing/2014/main" val="10007"/>
+                  </a:ext>
+                </a:extLst>
+              </a:tr>
+              <a:tr h="370840">
+                <a:tc vMerge="1">
+                  <a:txBody>
+                    <a:bodyPr/>
+                    <a:lstStyle/>
+                    <a:p>
+                      <a:endParaRPr lang="zh-CN"/>
                     </a:p>
                   </a:txBody>
                   <a:tcPr/>
@@ -4210,7 +5249,6 @@
                         <a:rPr lang="en-US" dirty="0"/>
                         <a:t>True</a:t>
                       </a:r>
-                      <a:endParaRPr lang="en-US" dirty="0"/>
                     </a:p>
                   </a:txBody>
                   <a:tcPr/>
@@ -4224,11 +5262,67 @@
                         <a:rPr lang="en-US" dirty="0"/>
                         <a:t>False</a:t>
                       </a:r>
-                      <a:endParaRPr lang="en-US" dirty="0"/>
                     </a:p>
                   </a:txBody>
                   <a:tcPr/>
                 </a:tc>
+                <a:tc>
+                  <a:txBody>
+                    <a:bodyPr/>
+                    <a:lstStyle/>
+                    <a:p>
+                      <a:r>
+                        <a:rPr lang="en-US" dirty="0"/>
+                        <a:t>True</a:t>
+                      </a:r>
+                    </a:p>
+                  </a:txBody>
+                  <a:tcPr/>
+                </a:tc>
+                <a:tc>
+                  <a:txBody>
+                    <a:bodyPr/>
+                    <a:lstStyle/>
+                    <a:p>
+                      <a:r>
+                        <a:rPr lang="en-US" dirty="0"/>
+                        <a:t>False</a:t>
+                      </a:r>
+                    </a:p>
+                  </a:txBody>
+                  <a:tcPr/>
+                </a:tc>
+                <a:tc>
+                  <a:txBody>
+                    <a:bodyPr/>
+                    <a:lstStyle/>
+                    <a:p>
+                      <a:r>
+                        <a:rPr lang="en-US" dirty="0"/>
+                        <a:t>True</a:t>
+                      </a:r>
+                    </a:p>
+                  </a:txBody>
+                  <a:tcPr/>
+                </a:tc>
+                <a:tc>
+                  <a:txBody>
+                    <a:bodyPr/>
+                    <a:lstStyle/>
+                    <a:p>
+                      <a:r>
+                        <a:rPr lang="en-US" dirty="0"/>
+                        <a:t>False</a:t>
+                      </a:r>
+                    </a:p>
+                  </a:txBody>
+                  <a:tcPr/>
+                </a:tc>
+                <a:extLst>
+                  <a:ext uri="{0D108BD9-81ED-4DB2-BD59-A6C34878D82A}">
+                    <a16:rowId xmlns:a16="http://schemas.microsoft.com/office/drawing/2014/main" val="10008"/>
+                  </a:ext>
+                </a:extLst>
               </a:tr>
             </a:tbl>
           </a:graphicData>
@@ -4278,7 +5372,6 @@
               <a:rPr lang="en-US" dirty="0"/>
               <a:t>Second slide title</a:t>
             </a:r>
-            <a:endParaRPr lang="en-US" dirty="0"/>
           </a:p>
         </p:txBody>
       </p:sp>
@@ -4309,21 +5402,18 @@
               <a:rPr lang="en-US" dirty="0"/>
               <a:t>Let’s introduce a list</a:t>
             </a:r>
-            <a:endParaRPr lang="en-US" dirty="0"/>
           </a:p>
           <a:p>
             <a:r>
               <a:rPr lang="en-US" dirty="0"/>
               <a:t>With foo</a:t>
             </a:r>
-            <a:endParaRPr lang="en-US" dirty="0"/>
           </a:p>
           <a:p>
             <a:r>
               <a:rPr lang="en-US" dirty="0"/>
               <a:t>Bar</a:t>
             </a:r>
-            <a:endParaRPr lang="en-US" dirty="0"/>
           </a:p>
           <a:p>
             <a:r>
@@ -4338,7 +5428,6 @@
               <a:rPr lang="en-US" dirty="0"/>
               <a:t> things</a:t>
             </a:r>
-            <a:endParaRPr lang="en-US" dirty="0"/>
           </a:p>
         </p:txBody>
       </p:sp>
@@ -4382,7 +5471,6 @@
               <a:rPr lang="en-US" dirty="0"/>
               <a:t>A rectangle shape with this text inside.</a:t>
             </a:r>
-            <a:endParaRPr lang="en-US" dirty="0"/>
           </a:p>
         </p:txBody>
       </p:sp>
@@ -4441,7 +5529,6 @@
               <a:rPr lang="en-US" dirty="0"/>
               <a:t>List item4</a:t>
             </a:r>
-            <a:endParaRPr lang="en-US" dirty="0"/>
           </a:p>
           <a:p>
             <a:pPr marL="342900" indent="-342900">
@@ -4452,7 +5539,6 @@
               <a:rPr lang="en-US" dirty="0"/>
               <a:t>List item5</a:t>
             </a:r>
-            <a:endParaRPr lang="en-US" dirty="0"/>
           </a:p>
           <a:p>
             <a:pPr marL="342900" indent="-342900">
@@ -4463,7 +5549,6 @@
               <a:rPr lang="en-US" dirty="0"/>
               <a:t>List item6</a:t>
             </a:r>
-            <a:endParaRPr lang="en-US" dirty="0"/>
           </a:p>
         </p:txBody>
       </p:sp>
@@ -4501,7 +5586,6 @@
               <a:rPr lang="en-US" dirty="0"/>
               <a:t>1</a:t>
             </a:r>
-            <a:endParaRPr lang="en-US" dirty="0"/>
           </a:p>
           <a:p>
             <a:pPr marL="285750" indent="-285750">
@@ -4512,7 +5596,6 @@
               <a:rPr lang="en-US" dirty="0"/>
               <a:t>I2</a:t>
             </a:r>
-            <a:endParaRPr lang="en-US" dirty="0"/>
           </a:p>
           <a:p>
             <a:pPr marL="285750" indent="-285750">
@@ -4523,7 +5606,6 @@
               <a:rPr lang="en-US" dirty="0"/>
               <a:t>I3</a:t>
             </a:r>
-            <a:endParaRPr lang="en-US" dirty="0"/>
           </a:p>
           <a:p>
             <a:pPr marL="285750" indent="-285750">
@@ -4534,7 +5616,6 @@
               <a:rPr lang="en-US" dirty="0"/>
               <a:t>I4</a:t>
             </a:r>
-            <a:endParaRPr lang="en-US" dirty="0"/>
           </a:p>
         </p:txBody>
       </p:sp>
@@ -4568,7 +5649,6 @@
               <a:rPr lang="en-US" dirty="0"/>
               <a:t>ome info:</a:t>
             </a:r>
-            <a:endParaRPr lang="en-US" dirty="0"/>
           </a:p>
           <a:p>
             <a:pPr marL="285750" indent="-285750">
@@ -4583,7 +5663,6 @@
               <a:rPr lang="en-US" dirty="0"/>
               <a:t>tem A</a:t>
             </a:r>
-            <a:endParaRPr lang="en-US" dirty="0"/>
           </a:p>
           <a:p>
             <a:pPr marL="285750" indent="-285750">
@@ -4594,7 +5673,6 @@
               <a:rPr lang="en-US" dirty="0"/>
               <a:t>Item B</a:t>
             </a:r>
-            <a:endParaRPr lang="en-US" dirty="0"/>
           </a:p>
         </p:txBody>
       </p:sp>
@@ -4628,7 +5706,6 @@
               <a:rPr lang="en-US" dirty="0"/>
               <a:t>aybe a list?</a:t>
             </a:r>
-            <a:endParaRPr lang="en-US" dirty="0"/>
           </a:p>
           <a:p>
             <a:pPr marL="342900" indent="-342900">
@@ -4639,7 +5716,6 @@
               <a:rPr lang="en-US" dirty="0"/>
               <a:t>List1</a:t>
             </a:r>
-            <a:endParaRPr lang="en-US" dirty="0"/>
           </a:p>
           <a:p>
             <a:pPr marL="342900" indent="-342900">
@@ -4650,7 +5726,6 @@
               <a:rPr lang="en-US" dirty="0"/>
               <a:t>List2</a:t>
             </a:r>
-            <a:endParaRPr lang="en-US" dirty="0"/>
           </a:p>
           <a:p>
             <a:pPr marL="342900" indent="-342900">
@@ -4661,7 +5736,6 @@
               <a:rPr lang="en-US" dirty="0"/>
               <a:t>List3</a:t>
             </a:r>
-            <a:endParaRPr lang="en-US" dirty="0"/>
           </a:p>
         </p:txBody>
       </p:sp>
@@ -4695,7 +5769,6 @@
               <a:rPr lang="en-GB" dirty="0"/>
               <a:t>l1 </a:t>
             </a:r>
-            <a:endParaRPr lang="en-GB" dirty="0"/>
           </a:p>
           <a:p>
             <a:pPr marL="285750" indent="-285750">
@@ -4706,7 +5779,6 @@
               <a:rPr lang="en-GB" dirty="0"/>
               <a:t>l2</a:t>
             </a:r>
-            <a:endParaRPr lang="en-GB" dirty="0"/>
           </a:p>
           <a:p>
             <a:pPr marL="285750" indent="-285750">
@@ -4717,7 +5789,6 @@
               <a:rPr lang="en-US" dirty="0"/>
               <a:t>l3</a:t>
             </a:r>
-            <a:endParaRPr lang="en-US" dirty="0"/>
           </a:p>
         </p:txBody>
       </p:sp>
@@ -4738,7 +5809,14 @@
         <p:cNvGrpSpPr/>
         <p:nvPr/>
       </p:nvGrpSpPr>
-      <p:grpSpPr/>
+      <p:grpSpPr>
+        <a:xfrm>
+          <a:off x="0" y="0"/>
+          <a:ext cx="0" cy="0"/>
+          <a:chOff x="0" y="0"/>
+          <a:chExt cx="0" cy="0"/>
+        </a:xfrm>
+      </p:grpSpPr>
       <p:pic>
         <p:nvPicPr>
           <p:cNvPr id="5" name="图片 4" descr="20250807-172441"/>
@@ -4748,7 +5826,7 @@
           <p:nvPr/>
         </p:nvPicPr>
         <p:blipFill>
-          <a:blip r:embed="rId1"/>
+          <a:blip r:embed="rId2"/>
           <a:stretch>
             <a:fillRect/>
           </a:stretch>
@@ -4763,8 +5841,8 @@
           </a:prstGeom>
         </p:spPr>
       </p:pic>
-      <mc:AlternateContent xmlns:mc="http://schemas.openxmlformats.org/markup-compatibility/2006">
-        <mc:Choice xmlns:a14="http://schemas.microsoft.com/office/drawing/2010/main" Requires="a14">
+      <mc:AlternateContent xmlns:mc="http://schemas.openxmlformats.org/markup-compatibility/2006" xmlns:a14="http://schemas.microsoft.com/office/drawing/2010/main">
+        <mc:Choice Requires="a14">
           <p:sp>
             <p:nvSpPr>
               <p:cNvPr id="2" name="文本框 1"/>
@@ -4785,6 +5863,7 @@
               <a:bodyPr wrap="square" rtlCol="0">
                 <a:spAutoFit/>
               </a:bodyPr>
+              <a:lstStyle/>
               <a:p>
                 <a:r>
                   <a:rPr lang="zh-CN" altLang="en-US">
@@ -4798,7 +5877,7 @@
                   <m:oMath xmlns:m="http://schemas.openxmlformats.org/officeDocument/2006/math">
                     <m:r>
                       <a:rPr lang="en-US" altLang="zh-CN" i="1">
-                        <a:latin typeface="DejaVu Math TeX Gyre" panose="02000503000000000000" charset="0"/>
+                        <a:latin typeface="Cambria Math" panose="02040503050406030204" pitchFamily="18" charset="0"/>
                         <a:cs typeface="DejaVu Math TeX Gyre" panose="02000503000000000000" charset="0"/>
                       </a:rPr>
                       <m:t>𝑓</m:t>
@@ -4807,7 +5886,7 @@
                       <m:dPr>
                         <m:ctrlPr>
                           <a:rPr lang="en-US" altLang="zh-CN" i="1">
-                            <a:latin typeface="DejaVu Math TeX Gyre" panose="02000503000000000000" charset="0"/>
+                            <a:latin typeface="Cambria Math" panose="02040503050406030204" pitchFamily="18" charset="0"/>
                             <a:cs typeface="DejaVu Math TeX Gyre" panose="02000503000000000000" charset="0"/>
                           </a:rPr>
                         </m:ctrlPr>
@@ -4815,7 +5894,7 @@
                       <m:e>
                         <m:r>
                           <a:rPr lang="en-US" altLang="zh-CN" i="1">
-                            <a:latin typeface="DejaVu Math TeX Gyre" panose="02000503000000000000" charset="0"/>
+                            <a:latin typeface="Cambria Math" panose="02040503050406030204" pitchFamily="18" charset="0"/>
                             <a:cs typeface="DejaVu Math TeX Gyre" panose="02000503000000000000" charset="0"/>
                           </a:rPr>
                           <m:t>𝑥</m:t>
@@ -4824,7 +5903,7 @@
                     </m:d>
                     <m:r>
                       <a:rPr lang="en-US" altLang="zh-CN" i="1">
-                        <a:latin typeface="DejaVu Math TeX Gyre" panose="02000503000000000000" charset="0"/>
+                        <a:latin typeface="Cambria Math" panose="02040503050406030204" pitchFamily="18" charset="0"/>
                         <a:cs typeface="DejaVu Math TeX Gyre" panose="02000503000000000000" charset="0"/>
                       </a:rPr>
                       <m:t>=</m:t>
@@ -4833,7 +5912,7 @@
                       <m:sSubPr>
                         <m:ctrlPr>
                           <a:rPr lang="en-US" altLang="zh-CN" i="1">
-                            <a:latin typeface="DejaVu Math TeX Gyre" panose="02000503000000000000" charset="0"/>
+                            <a:latin typeface="Cambria Math" panose="02040503050406030204" pitchFamily="18" charset="0"/>
                             <a:cs typeface="DejaVu Math TeX Gyre" panose="02000503000000000000" charset="0"/>
                           </a:rPr>
                         </m:ctrlPr>
@@ -4841,7 +5920,7 @@
                       <m:e>
                         <m:r>
                           <a:rPr lang="en-US" altLang="zh-CN" i="1">
-                            <a:latin typeface="DejaVu Math TeX Gyre" panose="02000503000000000000" charset="0"/>
+                            <a:latin typeface="Cambria Math" panose="02040503050406030204" pitchFamily="18" charset="0"/>
                             <a:cs typeface="DejaVu Math TeX Gyre" panose="02000503000000000000" charset="0"/>
                           </a:rPr>
                           <m:t>𝑎</m:t>
@@ -4850,7 +5929,7 @@
                       <m:sub>
                         <m:r>
                           <a:rPr lang="en-US" altLang="zh-CN" i="1">
-                            <a:latin typeface="DejaVu Math TeX Gyre" panose="02000503000000000000" charset="0"/>
+                            <a:latin typeface="Cambria Math" panose="02040503050406030204" pitchFamily="18" charset="0"/>
                             <a:cs typeface="DejaVu Math TeX Gyre" panose="02000503000000000000" charset="0"/>
                           </a:rPr>
                           <m:t>0</m:t>
@@ -4859,7 +5938,7 @@
                     </m:sSub>
                     <m:r>
                       <a:rPr lang="en-US" altLang="zh-CN" i="1">
-                        <a:latin typeface="DejaVu Math TeX Gyre" panose="02000503000000000000" charset="0"/>
+                        <a:latin typeface="Cambria Math" panose="02040503050406030204" pitchFamily="18" charset="0"/>
                         <a:cs typeface="DejaVu Math TeX Gyre" panose="02000503000000000000" charset="0"/>
                       </a:rPr>
                       <m:t>+</m:t>
@@ -4870,7 +5949,7 @@
                         <m:limLoc m:val="undOvr"/>
                         <m:ctrlPr>
                           <a:rPr lang="en-US" altLang="zh-CN" i="1">
-                            <a:latin typeface="DejaVu Math TeX Gyre" panose="02000503000000000000" charset="0"/>
+                            <a:latin typeface="Cambria Math" panose="02040503050406030204" pitchFamily="18" charset="0"/>
                             <a:cs typeface="DejaVu Math TeX Gyre" panose="02000503000000000000" charset="0"/>
                           </a:rPr>
                         </m:ctrlPr>
@@ -4878,30 +5957,23 @@
                       <m:sub>
                         <m:r>
                           <a:rPr lang="en-US" altLang="zh-CN" i="1">
-                            <a:latin typeface="DejaVu Math TeX Gyre" panose="02000503000000000000" charset="0"/>
+                            <a:latin typeface="Cambria Math" panose="02040503050406030204" pitchFamily="18" charset="0"/>
                             <a:cs typeface="DejaVu Math TeX Gyre" panose="02000503000000000000" charset="0"/>
                           </a:rPr>
                           <m:t>𝑛</m:t>
                         </m:r>
                         <m:r>
                           <a:rPr lang="en-US" altLang="zh-CN" i="1">
-                            <a:latin typeface="DejaVu Math TeX Gyre" panose="02000503000000000000" charset="0"/>
+                            <a:latin typeface="Cambria Math" panose="02040503050406030204" pitchFamily="18" charset="0"/>
                             <a:cs typeface="DejaVu Math TeX Gyre" panose="02000503000000000000" charset="0"/>
                           </a:rPr>
-                          <m:t>=</m:t>
-                        </m:r>
-                        <m:r>
-                          <a:rPr lang="en-US" altLang="zh-CN" i="1">
-                            <a:latin typeface="DejaVu Math TeX Gyre" panose="02000503000000000000" charset="0"/>
-                            <a:cs typeface="DejaVu Math TeX Gyre" panose="02000503000000000000" charset="0"/>
-                          </a:rPr>
-                          <m:t>1</m:t>
+                          <m:t>=1</m:t>
                         </m:r>
                       </m:sub>
                       <m:sup>
                         <m:r>
                           <a:rPr lang="en-US" altLang="zh-CN" i="1">
-                            <a:latin typeface="DejaVu Math TeX Gyre" panose="02000503000000000000" charset="0"/>
+                            <a:latin typeface="Cambria Math" panose="02040503050406030204" pitchFamily="18" charset="0"/>
                             <a:cs typeface="DejaVu Math TeX Gyre" panose="02000503000000000000" charset="0"/>
                           </a:rPr>
                           <m:t>∞</m:t>
@@ -4912,7 +5984,7 @@
                           <m:dPr>
                             <m:ctrlPr>
                               <a:rPr lang="en-US" altLang="zh-CN" i="1">
-                                <a:latin typeface="DejaVu Math TeX Gyre" panose="02000503000000000000" charset="0"/>
+                                <a:latin typeface="Cambria Math" panose="02040503050406030204" pitchFamily="18" charset="0"/>
                                 <a:cs typeface="DejaVu Math TeX Gyre" panose="02000503000000000000" charset="0"/>
                               </a:rPr>
                             </m:ctrlPr>
@@ -4922,7 +5994,7 @@
                               <m:sSubPr>
                                 <m:ctrlPr>
                                   <a:rPr lang="en-US" altLang="zh-CN" i="1">
-                                    <a:latin typeface="DejaVu Math TeX Gyre" panose="02000503000000000000" charset="0"/>
+                                    <a:latin typeface="Cambria Math" panose="02040503050406030204" pitchFamily="18" charset="0"/>
                                     <a:cs typeface="DejaVu Math TeX Gyre" panose="02000503000000000000" charset="0"/>
                                   </a:rPr>
                                 </m:ctrlPr>
@@ -4930,7 +6002,7 @@
                               <m:e>
                                 <m:r>
                                   <a:rPr lang="en-US" altLang="zh-CN" i="1">
-                                    <a:latin typeface="DejaVu Math TeX Gyre" panose="02000503000000000000" charset="0"/>
+                                    <a:latin typeface="Cambria Math" panose="02040503050406030204" pitchFamily="18" charset="0"/>
                                     <a:cs typeface="DejaVu Math TeX Gyre" panose="02000503000000000000" charset="0"/>
                                   </a:rPr>
                                   <m:t>𝑎</m:t>
@@ -4939,7 +6011,7 @@
                               <m:sub>
                                 <m:r>
                                   <a:rPr lang="en-US" altLang="zh-CN" i="1">
-                                    <a:latin typeface="DejaVu Math TeX Gyre" panose="02000503000000000000" charset="0"/>
+                                    <a:latin typeface="Cambria Math" panose="02040503050406030204" pitchFamily="18" charset="0"/>
                                     <a:cs typeface="DejaVu Math TeX Gyre" panose="02000503000000000000" charset="0"/>
                                   </a:rPr>
                                   <m:t>𝑛</m:t>
@@ -4949,8 +6021,8 @@
                             <m:func>
                               <m:funcPr>
                                 <m:ctrlPr>
-                                  <a:rPr lang="en-US" altLang="zh-CN">
-                                    <a:latin typeface="DejaVu Math TeX Gyre" panose="02000503000000000000" charset="0"/>
+                                  <a:rPr lang="en-US" altLang="zh-CN" i="1">
+                                    <a:latin typeface="Cambria Math" panose="02040503050406030204" pitchFamily="18" charset="0"/>
                                     <a:cs typeface="DejaVu Math TeX Gyre" panose="02000503000000000000" charset="0"/>
                                   </a:rPr>
                                 </m:ctrlPr>
@@ -4961,7 +6033,7 @@
                                     <m:sty m:val="p"/>
                                   </m:rPr>
                                   <a:rPr lang="en-US" altLang="zh-CN">
-                                    <a:latin typeface="DejaVu Math TeX Gyre" panose="02000503000000000000" charset="0"/>
+                                    <a:latin typeface="Cambria Math" panose="02040503050406030204" pitchFamily="18" charset="0"/>
                                     <a:cs typeface="DejaVu Math TeX Gyre" panose="02000503000000000000" charset="0"/>
                                   </a:rPr>
                                   <m:t>cos</m:t>
@@ -4972,7 +6044,7 @@
                                   <m:fPr>
                                     <m:ctrlPr>
                                       <a:rPr lang="en-US" altLang="zh-CN" i="1">
-                                        <a:latin typeface="DejaVu Math TeX Gyre" panose="02000503000000000000" charset="0"/>
+                                        <a:latin typeface="Cambria Math" panose="02040503050406030204" pitchFamily="18" charset="0"/>
                                         <a:cs typeface="DejaVu Math TeX Gyre" panose="02000503000000000000" charset="0"/>
                                       </a:rPr>
                                     </m:ctrlPr>
@@ -4980,21 +6052,21 @@
                                   <m:num>
                                     <m:r>
                                       <a:rPr lang="en-US" altLang="zh-CN" i="1">
-                                        <a:latin typeface="DejaVu Math TeX Gyre" panose="02000503000000000000" charset="0"/>
+                                        <a:latin typeface="Cambria Math" panose="02040503050406030204" pitchFamily="18" charset="0"/>
                                         <a:cs typeface="DejaVu Math TeX Gyre" panose="02000503000000000000" charset="0"/>
                                       </a:rPr>
                                       <m:t>𝑛</m:t>
                                     </m:r>
                                     <m:r>
                                       <a:rPr lang="en-US" altLang="zh-CN" i="1">
-                                        <a:latin typeface="DejaVu Math TeX Gyre" panose="02000503000000000000" charset="0"/>
+                                        <a:latin typeface="Cambria Math" panose="02040503050406030204" pitchFamily="18" charset="0"/>
                                         <a:cs typeface="DejaVu Math TeX Gyre" panose="02000503000000000000" charset="0"/>
                                       </a:rPr>
                                       <m:t>𝜋</m:t>
                                     </m:r>
                                     <m:r>
                                       <a:rPr lang="en-US" altLang="zh-CN" i="1">
-                                        <a:latin typeface="DejaVu Math TeX Gyre" panose="02000503000000000000" charset="0"/>
+                                        <a:latin typeface="Cambria Math" panose="02040503050406030204" pitchFamily="18" charset="0"/>
                                         <a:cs typeface="DejaVu Math TeX Gyre" panose="02000503000000000000" charset="0"/>
                                       </a:rPr>
                                       <m:t>𝑥</m:t>
@@ -5003,7 +6075,7 @@
                                   <m:den>
                                     <m:r>
                                       <a:rPr lang="en-US" altLang="zh-CN" i="1">
-                                        <a:latin typeface="DejaVu Math TeX Gyre" panose="02000503000000000000" charset="0"/>
+                                        <a:latin typeface="Cambria Math" panose="02040503050406030204" pitchFamily="18" charset="0"/>
                                         <a:cs typeface="DejaVu Math TeX Gyre" panose="02000503000000000000" charset="0"/>
                                       </a:rPr>
                                       <m:t>𝐿</m:t>
@@ -5014,7 +6086,7 @@
                             </m:func>
                             <m:r>
                               <a:rPr lang="en-US" altLang="zh-CN" i="1">
-                                <a:latin typeface="DejaVu Math TeX Gyre" panose="02000503000000000000" charset="0"/>
+                                <a:latin typeface="Cambria Math" panose="02040503050406030204" pitchFamily="18" charset="0"/>
                                 <a:cs typeface="DejaVu Math TeX Gyre" panose="02000503000000000000" charset="0"/>
                               </a:rPr>
                               <m:t>+</m:t>
@@ -5023,7 +6095,7 @@
                               <m:sSubPr>
                                 <m:ctrlPr>
                                   <a:rPr lang="en-US" altLang="zh-CN" i="1">
-                                    <a:latin typeface="DejaVu Math TeX Gyre" panose="02000503000000000000" charset="0"/>
+                                    <a:latin typeface="Cambria Math" panose="02040503050406030204" pitchFamily="18" charset="0"/>
                                     <a:cs typeface="DejaVu Math TeX Gyre" panose="02000503000000000000" charset="0"/>
                                   </a:rPr>
                                 </m:ctrlPr>
@@ -5031,7 +6103,7 @@
                               <m:e>
                                 <m:r>
                                   <a:rPr lang="en-US" altLang="zh-CN" i="1">
-                                    <a:latin typeface="DejaVu Math TeX Gyre" panose="02000503000000000000" charset="0"/>
+                                    <a:latin typeface="Cambria Math" panose="02040503050406030204" pitchFamily="18" charset="0"/>
                                     <a:cs typeface="DejaVu Math TeX Gyre" panose="02000503000000000000" charset="0"/>
                                   </a:rPr>
                                   <m:t>𝑏</m:t>
@@ -5040,7 +6112,7 @@
                               <m:sub>
                                 <m:r>
                                   <a:rPr lang="en-US" altLang="zh-CN" i="1">
-                                    <a:latin typeface="DejaVu Math TeX Gyre" panose="02000503000000000000" charset="0"/>
+                                    <a:latin typeface="Cambria Math" panose="02040503050406030204" pitchFamily="18" charset="0"/>
                                     <a:cs typeface="DejaVu Math TeX Gyre" panose="02000503000000000000" charset="0"/>
                                   </a:rPr>
                                   <m:t>𝑛</m:t>
@@ -5050,8 +6122,8 @@
                             <m:func>
                               <m:funcPr>
                                 <m:ctrlPr>
-                                  <a:rPr lang="en-US" altLang="zh-CN">
-                                    <a:latin typeface="DejaVu Math TeX Gyre" panose="02000503000000000000" charset="0"/>
+                                  <a:rPr lang="en-US" altLang="zh-CN" i="1">
+                                    <a:latin typeface="Cambria Math" panose="02040503050406030204" pitchFamily="18" charset="0"/>
                                     <a:cs typeface="DejaVu Math TeX Gyre" panose="02000503000000000000" charset="0"/>
                                   </a:rPr>
                                 </m:ctrlPr>
@@ -5062,7 +6134,7 @@
                                     <m:sty m:val="p"/>
                                   </m:rPr>
                                   <a:rPr lang="en-US" altLang="zh-CN">
-                                    <a:latin typeface="DejaVu Math TeX Gyre" panose="02000503000000000000" charset="0"/>
+                                    <a:latin typeface="Cambria Math" panose="02040503050406030204" pitchFamily="18" charset="0"/>
                                     <a:cs typeface="DejaVu Math TeX Gyre" panose="02000503000000000000" charset="0"/>
                                   </a:rPr>
                                   <m:t>sin</m:t>
@@ -5073,7 +6145,7 @@
                                   <m:fPr>
                                     <m:ctrlPr>
                                       <a:rPr lang="en-US" altLang="zh-CN" i="1">
-                                        <a:latin typeface="DejaVu Math TeX Gyre" panose="02000503000000000000" charset="0"/>
+                                        <a:latin typeface="Cambria Math" panose="02040503050406030204" pitchFamily="18" charset="0"/>
                                         <a:cs typeface="DejaVu Math TeX Gyre" panose="02000503000000000000" charset="0"/>
                                       </a:rPr>
                                     </m:ctrlPr>
@@ -5081,21 +6153,21 @@
                                   <m:num>
                                     <m:r>
                                       <a:rPr lang="en-US" altLang="zh-CN" i="1">
-                                        <a:latin typeface="DejaVu Math TeX Gyre" panose="02000503000000000000" charset="0"/>
+                                        <a:latin typeface="Cambria Math" panose="02040503050406030204" pitchFamily="18" charset="0"/>
                                         <a:cs typeface="DejaVu Math TeX Gyre" panose="02000503000000000000" charset="0"/>
                                       </a:rPr>
                                       <m:t>𝑛</m:t>
                                     </m:r>
                                     <m:r>
                                       <a:rPr lang="en-US" altLang="zh-CN" i="1">
-                                        <a:latin typeface="DejaVu Math TeX Gyre" panose="02000503000000000000" charset="0"/>
+                                        <a:latin typeface="Cambria Math" panose="02040503050406030204" pitchFamily="18" charset="0"/>
                                         <a:cs typeface="DejaVu Math TeX Gyre" panose="02000503000000000000" charset="0"/>
                                       </a:rPr>
                                       <m:t>𝜋</m:t>
                                     </m:r>
                                     <m:r>
                                       <a:rPr lang="en-US" altLang="zh-CN" i="1">
-                                        <a:latin typeface="DejaVu Math TeX Gyre" panose="02000503000000000000" charset="0"/>
+                                        <a:latin typeface="Cambria Math" panose="02040503050406030204" pitchFamily="18" charset="0"/>
                                         <a:cs typeface="DejaVu Math TeX Gyre" panose="02000503000000000000" charset="0"/>
                                       </a:rPr>
                                       <m:t>𝑥</m:t>
@@ -5104,7 +6176,7 @@
                                   <m:den>
                                     <m:r>
                                       <a:rPr lang="en-US" altLang="zh-CN" i="1">
-                                        <a:latin typeface="DejaVu Math TeX Gyre" panose="02000503000000000000" charset="0"/>
+                                        <a:latin typeface="Cambria Math" panose="02040503050406030204" pitchFamily="18" charset="0"/>
                                         <a:cs typeface="DejaVu Math TeX Gyre" panose="02000503000000000000" charset="0"/>
                                       </a:rPr>
                                       <m:t>𝐿</m:t>
@@ -5127,16 +6199,11 @@
                   </a:rPr>
                   <a:t>公式后</a:t>
                 </a:r>
-                <a:endParaRPr lang="zh-CN" altLang="en-US">
-                  <a:latin typeface="DejaVu Math TeX Gyre" panose="02000503000000000000" charset="0"/>
-                  <a:ea typeface="宋体" charset="0"/>
-                  <a:cs typeface="DejaVu Math TeX Gyre" panose="02000503000000000000" charset="0"/>
-                </a:endParaRPr>
               </a:p>
             </p:txBody>
           </p:sp>
         </mc:Choice>
-        <mc:Fallback>
+        <mc:Fallback xmlns="">
           <p:sp>
             <p:nvSpPr>
               <p:cNvPr id="2" name="文本框 1"/>
@@ -5154,7 +6221,7 @@
                 <a:avLst/>
               </a:prstGeom>
               <a:blipFill rotWithShape="1">
-                <a:blip r:embed="rId2"/>
+                <a:blip r:embed="rId3"/>
                 <a:stretch>
                   <a:fillRect/>
                 </a:stretch>
@@ -5195,6 +6262,7 @@
           <a:bodyPr wrap="square" rtlCol="0">
             <a:spAutoFit/>
           </a:bodyPr>
+          <a:lstStyle/>
           <a:p>
             <a:r>
               <a:rPr lang="zh-CN" altLang="en-US"/>
@@ -5246,13 +6314,107 @@
               </a:rPr>
               <a:t>删除线</a:t>
             </a:r>
-            <a:endParaRPr lang="zh-CN" altLang="en-US" strike="sngStrike">
-              <a:ea typeface="宋体" charset="0"/>
-            </a:endParaRPr>
           </a:p>
         </p:txBody>
       </p:sp>
     </p:spTree>
+  </p:cSld>
+  <p:clrMapOvr>
+    <a:masterClrMapping/>
+  </p:clrMapOvr>
+</p:sld>
+</file>
+
+<file path=ppt/slides/slide5.xml><?xml version="1.0" encoding="utf-8"?>
+<p:sld xmlns:a="http://schemas.openxmlformats.org/drawingml/2006/main" xmlns:r="http://schemas.openxmlformats.org/officeDocument/2006/relationships" xmlns:p="http://schemas.openxmlformats.org/presentationml/2006/main">
+  <p:cSld>
+    <p:spTree>
+      <p:nvGrpSpPr>
+        <p:cNvPr id="1" name=""/>
+        <p:cNvGrpSpPr/>
+        <p:nvPr/>
+      </p:nvGrpSpPr>
+      <p:grpSpPr>
+        <a:xfrm>
+          <a:off x="0" y="0"/>
+          <a:ext cx="0" cy="0"/>
+          <a:chOff x="0" y="0"/>
+          <a:chExt cx="0" cy="0"/>
+        </a:xfrm>
+      </p:grpSpPr>
+      <p:sp>
+        <p:nvSpPr>
+          <p:cNvPr id="2" name="标题 1">
+            <a:extLst>
+              <a:ext uri="{FF2B5EF4-FFF2-40B4-BE49-F238E27FC236}">
+                <a16:creationId xmlns:a16="http://schemas.microsoft.com/office/drawing/2014/main" id="{10260EBD-E81F-5986-A110-AA091AC211A9}"/>
+              </a:ext>
+            </a:extLst>
+          </p:cNvPr>
+          <p:cNvSpPr>
+            <a:spLocks noGrp="1"/>
+          </p:cNvSpPr>
+          <p:nvPr>
+            <p:ph type="title"/>
+          </p:nvPr>
+        </p:nvSpPr>
+        <p:spPr/>
+        <p:txBody>
+          <a:bodyPr/>
+          <a:lstStyle/>
+          <a:p>
+            <a:r>
+              <a:rPr kumimoji="1" lang="zh-CN" altLang="en-US"/>
+              <a:t>第</a:t>
+            </a:r>
+            <a:r>
+              <a:rPr kumimoji="1" lang="en-US" altLang="zh-CN"/>
+              <a:t>5</a:t>
+            </a:r>
+            <a:r>
+              <a:rPr kumimoji="1" lang="zh-CN" altLang="en-US"/>
+              <a:t>页标题</a:t>
+            </a:r>
+          </a:p>
+        </p:txBody>
+      </p:sp>
+      <p:graphicFrame>
+        <p:nvGraphicFramePr>
+          <p:cNvPr id="4" name="内容占位符 3">
+            <a:extLst>
+              <a:ext uri="{FF2B5EF4-FFF2-40B4-BE49-F238E27FC236}">
+                <a16:creationId xmlns:a16="http://schemas.microsoft.com/office/drawing/2014/main" id="{8ED5A772-4B85-22FA-93BD-84D0B14D7A1D}"/>
+              </a:ext>
+            </a:extLst>
+          </p:cNvPr>
+          <p:cNvGraphicFramePr>
+            <a:graphicFrameLocks noGrp="1"/>
+          </p:cNvGraphicFramePr>
+          <p:nvPr>
+            <p:ph idx="1"/>
+            <p:extLst>
+              <p:ext uri="{D42A27DB-BD31-4B8C-83A1-F6EECF244321}">
+                <p14:modId xmlns:p14="http://schemas.microsoft.com/office/powerpoint/2010/main" val="2865934271"/>
+              </p:ext>
+            </p:extLst>
+          </p:nvPr>
+        </p:nvGraphicFramePr>
+        <p:xfrm>
+          <a:off x="838200" y="1825625"/>
+          <a:ext cx="10515600" cy="4351338"/>
+        </p:xfrm>
+        <a:graphic>
+          <a:graphicData uri="http://schemas.openxmlformats.org/drawingml/2006/chart">
+            <c:chart xmlns:c="http://schemas.openxmlformats.org/drawingml/2006/chart" xmlns:r="http://schemas.openxmlformats.org/officeDocument/2006/relationships" r:id="rId2"/>
+          </a:graphicData>
+        </a:graphic>
+      </p:graphicFrame>
+    </p:spTree>
+    <p:extLst>
+      <p:ext uri="{BB962C8B-B14F-4D97-AF65-F5344CB8AC3E}">
+        <p14:creationId xmlns:p14="http://schemas.microsoft.com/office/powerpoint/2010/main" val="2316548462"/>
+      </p:ext>
+    </p:extLst>
   </p:cSld>
   <p:clrMapOvr>
     <a:masterClrMapping/>
@@ -5532,6 +6694,7 @@
       </a:style>
     </a:lnDef>
   </a:objectDefaults>
+  <a:extraClrSchemeLst/>
   <a:extLst>
     <a:ext uri="{05A4C25C-085E-4340-85A3-A5531E510DB2}">
       <thm15:themeFamily xmlns:thm15="http://schemas.microsoft.com/office/thememl/2012/main" name="Office Theme" id="{62F939B6-93AF-4DB8-9C6B-D6C7DFDC589F}" vid="{4A3C46E8-61CC-4603-A589-7422A47A8E4A}"/>
@@ -5856,6 +7019,7 @@
       </a:style>
     </a:lnDef>
   </a:objectDefaults>
+  <a:extraClrSchemeLst/>
   <a:extLst>
     <a:ext uri="{05A4C25C-085E-4340-85A3-A5531E510DB2}">
       <thm15:themeFamily xmlns:thm15="http://schemas.microsoft.com/office/thememl/2012/main" name="Office Theme" id="{62F939B6-93AF-4DB8-9C6B-D6C7DFDC589F}" vid="{4A3C46E8-61CC-4603-A589-7422A47A8E4A}"/>

</xml_diff>